<commit_message>
Update official Team DEKO details (Team ID: 141444, Leader: BALAJI P, UCE Panruti)
</commit_message>
<xml_diff>
--- a/SIH26094_KEFI_AI_OFFICIAL_SUBMISSION.pptx
+++ b/SIH26094_KEFI_AI_OFFICIAL_SUBMISSION.pptx
@@ -5660,7 +5660,7 @@
           </a:p>
           <a:p>
             <a:pPr>
-              <a:defRPr b="1" sz="1400">
+              <a:defRPr b="1" sz="1300">
                 <a:solidFill>
                   <a:srgbClr val="0F172A"/>
                 </a:solidFill>
@@ -5672,7 +5672,7 @@
           </a:p>
           <a:p>
             <a:pPr>
-              <a:defRPr sz="1300"/>
+              <a:defRPr sz="1200"/>
             </a:pPr>
             <a:r>
               <a:t>Theme / Technology Bucket: MedTech / BioTech / HealthTech (Software)</a:t>
@@ -5680,30 +5680,34 @@
           </a:p>
           <a:p>
             <a:pPr>
-              <a:defRPr sz="1300"/>
+              <a:defRPr sz="1200"/>
             </a:pPr>
             <a:r>
-              <a:t>PS Category: Software | Organization: Ministry of Social Justice and Empowerment (MoSJE)</a:t>
+              <a:t>PS Category: Software | Ministry: Ministry of Social Justice and Empowerment (MoSJE)</a:t>
             </a:r>
           </a:p>
           <a:p>
             <a:pPr>
-              <a:defRPr sz="1300"/>
-            </a:pPr>
-            <a:r>
-              <a:t>Team ID: SIH2026-KEFI-094</a:t>
-            </a:r>
-          </a:p>
-          <a:p>
-            <a:pPr>
-              <a:defRPr b="1" sz="1500">
+              <a:defRPr b="1" sz="1400">
                 <a:solidFill>
                   <a:srgbClr val="3A7070"/>
                 </a:solidFill>
               </a:defRPr>
             </a:pPr>
             <a:r>
-              <a:t>Team Name: KEFI AI</a:t>
+              <a:t>Team ID: 141444  |  Team Name: DEKO</a:t>
+            </a:r>
+          </a:p>
+          <a:p>
+            <a:pPr>
+              <a:defRPr b="1" sz="1200">
+                <a:solidFill>
+                  <a:srgbClr val="1E293B"/>
+                </a:solidFill>
+              </a:defRPr>
+            </a:pPr>
+            <a:r>
+              <a:t>Team Leader: BALAJI P  |  Institute: University College of Engineering, Panruti</a:t>
             </a:r>
           </a:p>
         </p:txBody>
@@ -5922,7 +5926,7 @@
               </a:defRPr>
             </a:pPr>
             <a:r>
-              <a:t>• Project Name &amp; Greek Origin: KEFI (Kinematic Emotion &amp; Forecasting Intervention System) — derived from Kéfi (Κέφι): spirit of joy, emotional vitality, resilience &amp; inner healing after trauma.</a:t>
+              <a:t>• Project Name &amp; Greek Origin: KEFI AI (Kinematic Emotion &amp; Forecasting Intervention System) — derived from Kéfi (Κέφι): spirit of joy, emotional vitality, resilience &amp; inner healing after trauma.</a:t>
             </a:r>
           </a:p>
           <a:p>
@@ -6102,7 +6106,7 @@
           <a:p>
             <a:pPr algn="ctr"/>
             <a:r>
-              <a:t>KEFI AI</a:t>
+              <a:t>DEKO</a:t>
             </a:r>
             <a:endParaRPr lang="en-IN" dirty="0"/>
           </a:p>
@@ -6481,7 +6485,7 @@
           <a:p>
             <a:pPr algn="ctr"/>
             <a:r>
-              <a:t>KEFI AI</a:t>
+              <a:t>DEKO</a:t>
             </a:r>
             <a:endParaRPr lang="en-IN" dirty="0"/>
           </a:p>
@@ -6985,7 +6989,7 @@
           <a:p>
             <a:pPr algn="ctr"/>
             <a:r>
-              <a:t>KEFI AI</a:t>
+              <a:t>DEKO</a:t>
             </a:r>
             <a:endParaRPr lang="en-IN" dirty="0"/>
           </a:p>
@@ -7480,7 +7484,7 @@
           <a:p>
             <a:pPr algn="ctr"/>
             <a:r>
-              <a:t>KEFI AI</a:t>
+              <a:t>DEKO</a:t>
             </a:r>
             <a:endParaRPr lang="en-IN" dirty="0"/>
           </a:p>
@@ -7771,7 +7775,7 @@
               </a:defRPr>
             </a:pPr>
             <a:r>
-              <a:t>• Official Project Repository &amp; Live Prototype: Full working source code, API backend &amp; React frontend available at e:\SIH Keffi platform with clean production build.</a:t>
+              <a:t>• Official Project Repository &amp; Live Prototype: Full working source code, API backend &amp; React frontend available at https://github.com/balajikrishnan031/SIH-KEFI</a:t>
             </a:r>
           </a:p>
         </p:txBody>
@@ -7974,7 +7978,7 @@
           <a:p>
             <a:pPr algn="ctr"/>
             <a:r>
-              <a:t>KEFI AI</a:t>
+              <a:t>DEKO</a:t>
             </a:r>
             <a:endParaRPr lang="en-IN" dirty="0"/>
           </a:p>

</xml_diff>

<commit_message>
Add Master DOCX & PDF Technical Report for Team DEKO
</commit_message>
<xml_diff>
--- a/SIH26094_KEFI_AI_OFFICIAL_SUBMISSION.pptx
+++ b/SIH26094_KEFI_AI_OFFICIAL_SUBMISSION.pptx
@@ -5667,7 +5667,7 @@
               </a:defRPr>
             </a:pPr>
             <a:r>
-              <a:t>Problem Statement Title: AI-Powered Dynamic Mental Health Monitoring and Distress Prediction System for Victims of Atrocities</a:t>
+              <a:t>Title: AI-Powered Dynamic Mental Health Monitoring and Distress Prediction System for Victims of Atrocities</a:t>
             </a:r>
           </a:p>
           <a:p>
@@ -5926,7 +5926,7 @@
               </a:defRPr>
             </a:pPr>
             <a:r>
-              <a:t>• Project Name &amp; Greek Origin: KEFI AI (Kinematic Emotion &amp; Forecasting Intervention System) — derived from Kéfi (Κέφι): spirit of joy, emotional vitality, resilience &amp; inner healing after trauma.</a:t>
+              <a:t>• Project Identity &amp; Greek Origin: KEFI AI (Kinematic Emotion &amp; Forecasting Intervention System) — derived from Kéfi (Κέφι): spirit of joy, emotional vitality, resilience &amp; inner healing after trauma.</a:t>
             </a:r>
           </a:p>
           <a:p>
@@ -5941,7 +5941,7 @@
               </a:defRPr>
             </a:pPr>
             <a:r>
-              <a:t>• Continuous Post-Complaint Monitoring: Proactively monitors crime victims (SC/ST PoA Act 1989 / NHAA 14566) across legal, investigation, court trial, compensation, and rehabilitation phases rather than waiting for crisis requests.</a:t>
+              <a:t>• Continuous Post-Complaint Monitoring: Proactively monitors crime victims (SC/ST PoA Act 1989 / NHAA 14566) across investigation, court trial, legal delay, compensation, and rehabilitation phases rather than waiting for crisis requests.</a:t>
             </a:r>
           </a:p>
           <a:p>

</xml_diff>

<commit_message>
Update official 6-slide SIH 2026 presentation (PPTX & PDF) matching exact reference structure of SIH1620_NextGen_coders
</commit_message>
<xml_diff>
--- a/SIH26094_KEFI_AI_OFFICIAL_SUBMISSION.pptx
+++ b/SIH26094_KEFI_AI_OFFICIAL_SUBMISSION.pptx
@@ -5499,84 +5499,6 @@
           </a:p>
         </p:txBody>
       </p:sp>
-      <p:pic>
-        <p:nvPicPr>
-          <p:cNvPr id="5" name="Picture 4">
-            <a:extLst>
-              <a:ext uri="{FF2B5EF4-FFF2-40B4-BE49-F238E27FC236}">
-                <a16:creationId xmlns:a16="http://schemas.microsoft.com/office/drawing/2014/main" id="{9120848B-B2B4-45BE-A961-AEC0B06CF41B}"/>
-              </a:ext>
-            </a:extLst>
-          </p:cNvPr>
-          <p:cNvPicPr>
-            <a:picLocks noChangeAspect="1"/>
-          </p:cNvPicPr>
-          <p:nvPr/>
-        </p:nvPicPr>
-        <p:blipFill rotWithShape="1">
-          <a:blip r:embed="rId2"/>
-          <a:srcRect r="59916"/>
-          <a:stretch/>
-        </p:blipFill>
-        <p:spPr>
-          <a:xfrm>
-            <a:off x="6854891" y="1715881"/>
-            <a:ext cx="3203509" cy="3426237"/>
-          </a:xfrm>
-          <a:prstGeom prst="rect">
-            <a:avLst/>
-          </a:prstGeom>
-        </p:spPr>
-      </p:pic>
-      <p:sp>
-        <p:nvSpPr>
-          <p:cNvPr id="4" name="Subtitle 3"/>
-          <p:cNvSpPr>
-            <a:spLocks noGrp="1"/>
-          </p:cNvSpPr>
-          <p:nvPr>
-            <p:ph type="subTitle" idx="1"/>
-          </p:nvPr>
-        </p:nvSpPr>
-        <p:spPr>
-          <a:xfrm>
-            <a:off x="1245686" y="648614"/>
-            <a:ext cx="8534400" cy="1752600"/>
-          </a:xfrm>
-        </p:spPr>
-        <p:txBody>
-          <a:bodyPr/>
-          <a:lstStyle/>
-          <a:p>
-            <a:endParaRPr lang="en-US" b="1" dirty="0">
-              <a:solidFill>
-                <a:schemeClr val="tx1"/>
-              </a:solidFill>
-              <a:latin typeface="Times New Roman" panose="02020603050405020304" pitchFamily="18" charset="0"/>
-              <a:cs typeface="Times New Roman" panose="02020603050405020304" pitchFamily="18" charset="0"/>
-            </a:endParaRPr>
-          </a:p>
-          <a:p>
-            <a:r>
-              <a:rPr lang="en-US" b="1" dirty="0">
-                <a:solidFill>
-                  <a:schemeClr val="tx1"/>
-                </a:solidFill>
-                <a:latin typeface="Times New Roman" panose="02020603050405020304" pitchFamily="18" charset="0"/>
-                <a:cs typeface="Times New Roman" panose="02020603050405020304" pitchFamily="18" charset="0"/>
-              </a:rPr>
-              <a:t>TITLE PAGE</a:t>
-            </a:r>
-            <a:endParaRPr lang="en-IN" b="1" dirty="0">
-              <a:solidFill>
-                <a:schemeClr val="tx1"/>
-              </a:solidFill>
-              <a:latin typeface="Times New Roman" panose="02020603050405020304" pitchFamily="18" charset="0"/>
-              <a:cs typeface="Times New Roman" panose="02020603050405020304" pitchFamily="18" charset="0"/>
-            </a:endParaRPr>
-          </a:p>
-        </p:txBody>
-      </p:sp>
       <p:sp>
         <p:nvSpPr>
           <p:cNvPr id="8" name="Title 7"/>
@@ -5621,94 +5543,6 @@
               </a:solidFill>
               <a:latin typeface="Garamond" panose="02020404030301010803" pitchFamily="18" charset="0"/>
             </a:endParaRPr>
-          </a:p>
-        </p:txBody>
-      </p:sp>
-      <p:sp>
-        <p:nvSpPr>
-          <p:cNvPr id="10" name="TextBox 9"/>
-          <p:cNvSpPr txBox="1"/>
-          <p:nvPr/>
-        </p:nvSpPr>
-        <p:spPr>
-          <a:xfrm>
-            <a:off x="331286" y="2076450"/>
-            <a:ext cx="5924550" cy="4703019"/>
-          </a:xfrm>
-          <a:prstGeom prst="rect">
-            <a:avLst/>
-          </a:prstGeom>
-          <a:noFill/>
-        </p:spPr>
-        <p:txBody>
-          <a:bodyPr wrap="square" rtlCol="0">
-            <a:spAutoFit/>
-          </a:bodyPr>
-          <a:lstStyle/>
-          <a:p>
-            <a:pPr>
-              <a:defRPr b="1" sz="1600">
-                <a:solidFill>
-                  <a:srgbClr val="0D5050"/>
-                </a:solidFill>
-              </a:defRPr>
-            </a:pPr>
-            <a:r>
-              <a:t>Problem Statement ID: SIH26094</a:t>
-            </a:r>
-            <a:endParaRPr lang="en-US" dirty="0"/>
-          </a:p>
-          <a:p>
-            <a:pPr>
-              <a:defRPr b="1" sz="1300">
-                <a:solidFill>
-                  <a:srgbClr val="0F172A"/>
-                </a:solidFill>
-              </a:defRPr>
-            </a:pPr>
-            <a:r>
-              <a:t>Title: AI-Powered Dynamic Mental Health Monitoring and Distress Prediction System for Victims of Atrocities</a:t>
-            </a:r>
-          </a:p>
-          <a:p>
-            <a:pPr>
-              <a:defRPr sz="1200"/>
-            </a:pPr>
-            <a:r>
-              <a:t>Theme / Technology Bucket: MedTech / BioTech / HealthTech (Software)</a:t>
-            </a:r>
-          </a:p>
-          <a:p>
-            <a:pPr>
-              <a:defRPr sz="1200"/>
-            </a:pPr>
-            <a:r>
-              <a:t>PS Category: Software | Ministry: Ministry of Social Justice and Empowerment (MoSJE)</a:t>
-            </a:r>
-          </a:p>
-          <a:p>
-            <a:pPr>
-              <a:defRPr b="1" sz="1400">
-                <a:solidFill>
-                  <a:srgbClr val="3A7070"/>
-                </a:solidFill>
-              </a:defRPr>
-            </a:pPr>
-            <a:r>
-              <a:t>Team ID: 141444  |  Team Name: DEKO</a:t>
-            </a:r>
-          </a:p>
-          <a:p>
-            <a:pPr>
-              <a:defRPr b="1" sz="1200">
-                <a:solidFill>
-                  <a:srgbClr val="1E293B"/>
-                </a:solidFill>
-              </a:defRPr>
-            </a:pPr>
-            <a:r>
-              <a:t>Team Leader: BALAJI P  |  Institute: University College of Engineering, Panruti</a:t>
-            </a:r>
           </a:p>
         </p:txBody>
       </p:sp>
@@ -5742,6 +5576,353 @@
           </a:prstGeom>
         </p:spPr>
       </p:pic>
+      <p:sp>
+        <p:nvSpPr>
+          <p:cNvPr id="38" name="TextBox 37"/>
+          <p:cNvSpPr txBox="1"/>
+          <p:nvPr/>
+        </p:nvSpPr>
+        <p:spPr>
+          <a:xfrm>
+            <a:off x="365760" y="1371600"/>
+            <a:ext cx="5120640" cy="4754880"/>
+          </a:xfrm>
+          <a:prstGeom prst="rect">
+            <a:avLst/>
+          </a:prstGeom>
+          <a:noFill/>
+        </p:spPr>
+        <p:txBody>
+          <a:bodyPr wrap="square" lIns="73152" rIns="73152" tIns="73152" bIns="73152">
+            <a:spAutoFit/>
+          </a:bodyPr>
+          <a:lstStyle/>
+          <a:p>
+            <a:pPr>
+              <a:spcAft>
+                <a:spcPts val="400"/>
+              </a:spcAft>
+            </a:pPr>
+            <a:r>
+              <a:rPr b="1" sz="1100">
+                <a:solidFill>
+                  <a:srgbClr val="0D5050"/>
+                </a:solidFill>
+              </a:rPr>
+              <a:t>• Problem Statement ID - </a:t>
+            </a:r>
+            <a:r>
+              <a:rPr b="1" sz="1100">
+                <a:solidFill>
+                  <a:srgbClr val="0F172A"/>
+                </a:solidFill>
+              </a:rPr>
+              <a:t>SIH26094</a:t>
+            </a:r>
+          </a:p>
+          <a:p>
+            <a:pPr>
+              <a:spcAft>
+                <a:spcPts val="400"/>
+              </a:spcAft>
+            </a:pPr>
+            <a:r>
+              <a:rPr b="1" sz="1100">
+                <a:solidFill>
+                  <a:srgbClr val="0D5050"/>
+                </a:solidFill>
+              </a:rPr>
+              <a:t>• Problem Statement Title - </a:t>
+            </a:r>
+            <a:r>
+              <a:rPr b="1" sz="1100">
+                <a:solidFill>
+                  <a:srgbClr val="0F172A"/>
+                </a:solidFill>
+              </a:rPr>
+              <a:t>AI-Powered Dynamic Mental Health Monitoring and Distress Prediction System for Victims of Atrocities</a:t>
+            </a:r>
+          </a:p>
+          <a:p>
+            <a:pPr>
+              <a:spcAft>
+                <a:spcPts val="400"/>
+              </a:spcAft>
+            </a:pPr>
+            <a:r>
+              <a:rPr b="1" sz="1100">
+                <a:solidFill>
+                  <a:srgbClr val="0D5050"/>
+                </a:solidFill>
+              </a:rPr>
+              <a:t>• Theme - </a:t>
+            </a:r>
+            <a:r>
+              <a:rPr b="0" sz="1100">
+                <a:solidFill>
+                  <a:srgbClr val="475569"/>
+                </a:solidFill>
+              </a:rPr>
+              <a:t>MedTech / BioTech / HealthTech</a:t>
+            </a:r>
+          </a:p>
+          <a:p>
+            <a:pPr>
+              <a:spcAft>
+                <a:spcPts val="400"/>
+              </a:spcAft>
+            </a:pPr>
+            <a:r>
+              <a:rPr b="1" sz="1100">
+                <a:solidFill>
+                  <a:srgbClr val="0D5050"/>
+                </a:solidFill>
+              </a:rPr>
+              <a:t>• PS Category - </a:t>
+            </a:r>
+            <a:r>
+              <a:rPr b="0" sz="1100">
+                <a:solidFill>
+                  <a:srgbClr val="475569"/>
+                </a:solidFill>
+              </a:rPr>
+              <a:t>Software</a:t>
+            </a:r>
+          </a:p>
+          <a:p>
+            <a:pPr>
+              <a:spcAft>
+                <a:spcPts val="400"/>
+              </a:spcAft>
+            </a:pPr>
+            <a:r>
+              <a:rPr b="1" sz="1100">
+                <a:solidFill>
+                  <a:srgbClr val="0D5050"/>
+                </a:solidFill>
+              </a:rPr>
+              <a:t>• Ministry - </a:t>
+            </a:r>
+            <a:r>
+              <a:rPr b="0" sz="1100">
+                <a:solidFill>
+                  <a:srgbClr val="475569"/>
+                </a:solidFill>
+              </a:rPr>
+              <a:t>Ministry of Social Justice and Empowerment (MoSJE)</a:t>
+            </a:r>
+          </a:p>
+          <a:p>
+            <a:pPr>
+              <a:spcAft>
+                <a:spcPts val="400"/>
+              </a:spcAft>
+            </a:pPr>
+            <a:r>
+              <a:rPr b="1" sz="1100">
+                <a:solidFill>
+                  <a:srgbClr val="0D5050"/>
+                </a:solidFill>
+              </a:rPr>
+              <a:t>• Team ID - </a:t>
+            </a:r>
+            <a:r>
+              <a:rPr b="1" sz="1100">
+                <a:solidFill>
+                  <a:srgbClr val="0F172A"/>
+                </a:solidFill>
+              </a:rPr>
+              <a:t>141444</a:t>
+            </a:r>
+          </a:p>
+          <a:p>
+            <a:pPr>
+              <a:spcAft>
+                <a:spcPts val="400"/>
+              </a:spcAft>
+            </a:pPr>
+            <a:r>
+              <a:rPr b="1" sz="1100">
+                <a:solidFill>
+                  <a:srgbClr val="0D5050"/>
+                </a:solidFill>
+              </a:rPr>
+              <a:t>• Team Name (Registered on portal) - </a:t>
+            </a:r>
+            <a:r>
+              <a:rPr b="1" sz="1100">
+                <a:solidFill>
+                  <a:srgbClr val="0F172A"/>
+                </a:solidFill>
+              </a:rPr>
+              <a:t>DEKO</a:t>
+            </a:r>
+          </a:p>
+          <a:p>
+            <a:pPr>
+              <a:spcAft>
+                <a:spcPts val="400"/>
+              </a:spcAft>
+            </a:pPr>
+            <a:r>
+              <a:rPr b="1" sz="1100">
+                <a:solidFill>
+                  <a:srgbClr val="0D5050"/>
+                </a:solidFill>
+              </a:rPr>
+              <a:t>• College - </a:t>
+            </a:r>
+            <a:r>
+              <a:rPr b="0" sz="1100">
+                <a:solidFill>
+                  <a:srgbClr val="475569"/>
+                </a:solidFill>
+              </a:rPr>
+              <a:t>University College of Engineering, Panruti</a:t>
+            </a:r>
+          </a:p>
+          <a:p>
+            <a:pPr>
+              <a:spcAft>
+                <a:spcPts val="400"/>
+              </a:spcAft>
+            </a:pPr>
+            <a:r>
+              <a:rPr b="1" sz="1100">
+                <a:solidFill>
+                  <a:srgbClr val="0D5050"/>
+                </a:solidFill>
+              </a:rPr>
+              <a:t>• Team Leader - </a:t>
+            </a:r>
+            <a:r>
+              <a:rPr b="1" sz="1100">
+                <a:solidFill>
+                  <a:srgbClr val="0F172A"/>
+                </a:solidFill>
+              </a:rPr>
+              <a:t>BALAJI P</a:t>
+            </a:r>
+          </a:p>
+        </p:txBody>
+      </p:sp>
+      <p:sp>
+        <p:nvSpPr>
+          <p:cNvPr id="39" name="Rounded Rectangle 38"/>
+          <p:cNvSpPr/>
+          <p:nvPr/>
+        </p:nvSpPr>
+        <p:spPr>
+          <a:xfrm>
+            <a:off x="5669280" y="1371600"/>
+            <a:ext cx="6035040" cy="4754880"/>
+          </a:xfrm>
+          <a:prstGeom prst="roundRect">
+            <a:avLst/>
+          </a:prstGeom>
+          <a:solidFill>
+            <a:srgbClr val="F5F8FA"/>
+          </a:solidFill>
+          <a:ln w="19050">
+            <a:solidFill>
+              <a:srgbClr val="CBD5E1"/>
+            </a:solidFill>
+          </a:ln>
+        </p:spPr>
+        <p:style>
+          <a:lnRef idx="1">
+            <a:schemeClr val="accent1"/>
+          </a:lnRef>
+          <a:fillRef idx="3">
+            <a:schemeClr val="accent1"/>
+          </a:fillRef>
+          <a:effectRef idx="2">
+            <a:schemeClr val="accent1"/>
+          </a:effectRef>
+          <a:fontRef idx="minor">
+            <a:schemeClr val="lt1"/>
+          </a:fontRef>
+        </p:style>
+        <p:txBody>
+          <a:bodyPr rtlCol="0" anchor="ctr" wrap="square" lIns="73152" rIns="73152" tIns="73152" bIns="73152"/>
+          <a:lstStyle/>
+          <a:p>
+            <a:pPr algn="ctr">
+              <a:spcAft>
+                <a:spcPts val="600"/>
+              </a:spcAft>
+              <a:defRPr b="1" sz="1300">
+                <a:solidFill>
+                  <a:srgbClr val="0D5050"/>
+                </a:solidFill>
+              </a:defRPr>
+            </a:pPr>
+            <a:r>
+              <a:t>Description:</a:t>
+            </a:r>
+          </a:p>
+          <a:p>
+            <a:pPr>
+              <a:spcAft>
+                <a:spcPts val="500"/>
+              </a:spcAft>
+              <a:defRPr sz="1000">
+                <a:solidFill>
+                  <a:srgbClr val="0F172A"/>
+                </a:solidFill>
+              </a:defRPr>
+            </a:pPr>
+            <a:r>
+              <a:t>• Victims of atrocities frequently experience prolonged psychological distress after complaint registration due to threats, intimidation, repeated court appearances, delays in investigation/trial, social ostracism, economic hardship, and rehabilitation challenges.</a:t>
+            </a:r>
+          </a:p>
+          <a:p>
+            <a:pPr>
+              <a:spcAft>
+                <a:spcPts val="500"/>
+              </a:spcAft>
+              <a:defRPr sz="1000">
+                <a:solidFill>
+                  <a:srgbClr val="0F172A"/>
+                </a:solidFill>
+              </a:defRPr>
+            </a:pPr>
+            <a:r>
+              <a:t>• Existing mechanisms focus primarily on post-hoc legal and financial compensation, leaving a critical void in continuous monitoring of victim well-being.</a:t>
+            </a:r>
+          </a:p>
+          <a:p>
+            <a:pPr>
+              <a:spcAft>
+                <a:spcPts val="500"/>
+              </a:spcAft>
+              <a:defRPr sz="1000">
+                <a:solidFill>
+                  <a:srgbClr val="0F172A"/>
+                </a:solidFill>
+              </a:defRPr>
+            </a:pPr>
+            <a:r>
+              <a:t>• Proposed Technological Solution: An AI-powered Dynamic Mental Health Monitoring &amp; Distress Prediction System (KEFI AI) integrated with NHAA (14566), IVRS calls, SMS, mobile applications, and web portal.</a:t>
+            </a:r>
+          </a:p>
+          <a:p>
+            <a:pPr>
+              <a:spcAft>
+                <a:spcPts val="500"/>
+              </a:spcAft>
+              <a:defRPr sz="1000">
+                <a:solidFill>
+                  <a:srgbClr val="0F172A"/>
+                </a:solidFill>
+              </a:defRPr>
+            </a:pPr>
+            <a:r>
+              <a:t>• Key Mandate: Continuously monitor psychological well-being, analyze multimodal signals (voice prosody, NLP sentiment, behavior), compute a Dynamic Distress Score (0–100), forecast crises 72 hours before escalation, and automatically alert District Magistrates (DM), SPs, and counsellors.</a:t>
+            </a:r>
+          </a:p>
+        </p:txBody>
+      </p:sp>
     </p:spTree>
   </p:cSld>
   <p:clrMapOvr>
@@ -5845,148 +6026,15 @@
           <a:bodyPr/>
           <a:lstStyle/>
           <a:p>
-            <a:pPr eaLnBrk="1" hangingPunct="1"/>
-            <a:r>
-              <a:rPr lang="en-US" sz="3600" b="1" dirty="0">
-                <a:latin typeface="Times New Roman" panose="02020603050405020304" pitchFamily="18" charset="0"/>
-                <a:ea typeface="ＭＳ Ｐゴシック" pitchFamily="1" charset="-128"/>
-                <a:cs typeface="Times New Roman" panose="02020603050405020304" pitchFamily="18" charset="0"/>
-              </a:rPr>
-              <a:t/>
-            </a:r>
-            <a:br>
-              <a:rPr lang="en-US" sz="3600" b="1" dirty="0">
-                <a:latin typeface="Times New Roman" panose="02020603050405020304" pitchFamily="18" charset="0"/>
-                <a:ea typeface="ＭＳ Ｐゴシック" pitchFamily="1" charset="-128"/>
-                <a:cs typeface="Times New Roman" panose="02020603050405020304" pitchFamily="18" charset="0"/>
-              </a:rPr>
-            </a:br>
-            <a:r>
-              <a:rPr lang="en-US" sz="3600" b="1" dirty="0">
-                <a:latin typeface="Times New Roman" panose="02020603050405020304" pitchFamily="18" charset="0"/>
-                <a:ea typeface="ＭＳ Ｐゴシック" pitchFamily="1" charset="-128"/>
-                <a:cs typeface="Times New Roman" panose="02020603050405020304" pitchFamily="18" charset="0"/>
-              </a:rPr>
-              <a:t>IDEA TITLE</a:t>
-            </a:r>
-          </a:p>
-        </p:txBody>
-      </p:sp>
-      <p:sp>
-        <p:nvSpPr>
-          <p:cNvPr id="15362" name="TextBox 8"/>
-          <p:cNvSpPr txBox="1">
-            <a:spLocks noChangeArrowheads="1"/>
-          </p:cNvSpPr>
-          <p:nvPr/>
-        </p:nvSpPr>
-        <p:spPr bwMode="auto">
-          <a:xfrm>
-            <a:off x="-1" y="2064921"/>
-            <a:ext cx="12191999" cy="2492990"/>
-          </a:xfrm>
-          <a:prstGeom prst="rect">
-            <a:avLst/>
-          </a:prstGeom>
-          <a:noFill/>
-          <a:ln w="9525">
-            <a:noFill/>
-            <a:miter lim="800000"/>
-            <a:headEnd/>
-            <a:tailEnd/>
-          </a:ln>
-        </p:spPr>
-        <p:txBody>
-          <a:bodyPr wrap="square">
-            <a:spAutoFit/>
-          </a:bodyPr>
-          <a:lstStyle/>
-          <a:p>
-            <a:pPr marL="342900" indent="-342900">
-              <a:buFont typeface="Wingdings" panose="05000000000000000000" pitchFamily="2" charset="2"/>
-              <a:buChar char="v"/>
-            </a:pPr>
-            <a:endParaRPr lang="en-US" sz="3200" u="sng" dirty="0">
-              <a:solidFill>
-                <a:schemeClr val="tx2"/>
-              </a:solidFill>
-              <a:latin typeface="Arial" pitchFamily="34" charset="0"/>
-              <a:cs typeface="Arial" pitchFamily="34" charset="0"/>
-            </a:endParaRPr>
-          </a:p>
-          <a:p>
             <a:pPr>
-              <a:spcAft>
-                <a:spcPts val="600"/>
-              </a:spcAft>
-              <a:defRPr sz="1200">
-                <a:solidFill>
-                  <a:srgbClr val="1E293B"/>
+              <a:defRPr b="1" sz="2800">
+                <a:solidFill>
+                  <a:srgbClr val="0F172A"/>
                 </a:solidFill>
               </a:defRPr>
             </a:pPr>
             <a:r>
-              <a:t>• Project Identity &amp; Greek Origin: KEFI AI (Kinematic Emotion &amp; Forecasting Intervention System) — derived from Kéfi (Κέφι): spirit of joy, emotional vitality, resilience &amp; inner healing after trauma.</a:t>
-            </a:r>
-          </a:p>
-          <a:p>
-            <a:pPr>
-              <a:spcAft>
-                <a:spcPts val="600"/>
-              </a:spcAft>
-              <a:defRPr sz="1200">
-                <a:solidFill>
-                  <a:srgbClr val="1E293B"/>
-                </a:solidFill>
-              </a:defRPr>
-            </a:pPr>
-            <a:r>
-              <a:t>• Continuous Post-Complaint Monitoring: Proactively monitors crime victims (SC/ST PoA Act 1989 / NHAA 14566) across investigation, court trial, legal delay, compensation, and rehabilitation phases rather than waiting for crisis requests.</a:t>
-            </a:r>
-          </a:p>
-          <a:p>
-            <a:pPr>
-              <a:spcAft>
-                <a:spcPts val="600"/>
-              </a:spcAft>
-              <a:defRPr sz="1200">
-                <a:solidFill>
-                  <a:srgbClr val="1E293B"/>
-                </a:solidFill>
-              </a:defRPr>
-            </a:pPr>
-            <a:r>
-              <a:t>• Multichannel Interaction Hub: Periodic check-ins via IVRS 14566 calls, Chatbot, SMS, Mobile App, and Web Portal with digital OTP consent &amp; AES-256 encryption.</a:t>
-            </a:r>
-          </a:p>
-          <a:p>
-            <a:pPr>
-              <a:spcAft>
-                <a:spcPts val="600"/>
-              </a:spcAft>
-              <a:defRPr sz="1200">
-                <a:solidFill>
-                  <a:srgbClr val="1E293B"/>
-                </a:solidFill>
-              </a:defRPr>
-            </a:pPr>
-            <a:r>
-              <a:t>• Dual-Risk Assessment Engine: 1) Immediate Physical Threat Check: Screens for active intimidation language. 2) Dynamic Distress Score (DDS): Multi-signal mathematical metric (DDS = w1*E + w2*V + w3*B + w4*H + w5*C + w6*T).</a:t>
-            </a:r>
-          </a:p>
-          <a:p>
-            <a:pPr>
-              <a:spcAft>
-                <a:spcPts val="600"/>
-              </a:spcAft>
-              <a:defRPr sz="1200">
-                <a:solidFill>
-                  <a:srgbClr val="1E293B"/>
-                </a:solidFill>
-              </a:defRPr>
-            </a:pPr>
-            <a:r>
-              <a:t>• 3-Tier Risk Bands &amp; Action Matrix: 🟢 Green/Yellow (0–30): Routine wellness check-ins &amp; self-help tools. 🟠 Orange (31–60): Focused check-ins &amp; scheduled tele-counselling. ⭕ Red (61–100): Real-time alert to District Magistrate (DM) / SP dashboard, witness protection &amp; crisis team dispatch.</a:t>
+              <a:t>PROPOSED SOLUTION</a:t>
             </a:r>
           </a:p>
         </p:txBody>
@@ -6104,11 +6152,16 @@
           <a:bodyPr rtlCol="0" anchor="ctr"/>
           <a:lstStyle/>
           <a:p>
-            <a:pPr algn="ctr"/>
+            <a:pPr>
+              <a:defRPr b="1" sz="1400">
+                <a:solidFill>
+                  <a:srgbClr val="0D5050"/>
+                </a:solidFill>
+              </a:defRPr>
+            </a:pPr>
             <a:r>
               <a:t>DEKO</a:t>
             </a:r>
-            <a:endParaRPr lang="en-IN" dirty="0"/>
           </a:p>
         </p:txBody>
       </p:sp>
@@ -6142,6 +6195,455 @@
           </a:prstGeom>
         </p:spPr>
       </p:pic>
+      <p:sp>
+        <p:nvSpPr>
+          <p:cNvPr id="15362" name="TextBox 15361"/>
+          <p:cNvSpPr txBox="1"/>
+          <p:nvPr/>
+        </p:nvSpPr>
+        <p:spPr>
+          <a:xfrm>
+            <a:off x="365760" y="1097280"/>
+            <a:ext cx="11338560" cy="3108960"/>
+          </a:xfrm>
+          <a:prstGeom prst="rect">
+            <a:avLst/>
+          </a:prstGeom>
+          <a:noFill/>
+        </p:spPr>
+        <p:txBody>
+          <a:bodyPr wrap="square" lIns="73152" rIns="73152" tIns="73152" bIns="73152">
+            <a:spAutoFit/>
+          </a:bodyPr>
+          <a:lstStyle/>
+          <a:p>
+            <a:pPr>
+              <a:spcAft>
+                <a:spcPts val="250"/>
+              </a:spcAft>
+            </a:pPr>
+            <a:r>
+              <a:rPr b="1" sz="1050">
+                <a:solidFill>
+                  <a:srgbClr val="0D5050"/>
+                </a:solidFill>
+              </a:rPr>
+              <a:t>• KEFI AI Identity &amp; Greek Origin: </a:t>
+            </a:r>
+            <a:r>
+              <a:rPr sz="1000">
+                <a:solidFill>
+                  <a:srgbClr val="0F172A"/>
+                </a:solidFill>
+              </a:rPr>
+              <a:t>KEFI AI (Kinematic Emotion &amp; Forecasting Intervention System) — derived from Kéfi (Κέφι): spirit of joy, emotional vitality, passion &amp; inner healing after trauma.</a:t>
+            </a:r>
+          </a:p>
+          <a:p>
+            <a:pPr>
+              <a:spcAft>
+                <a:spcPts val="250"/>
+              </a:spcAft>
+            </a:pPr>
+            <a:r>
+              <a:rPr b="1" sz="1050">
+                <a:solidFill>
+                  <a:srgbClr val="0D5050"/>
+                </a:solidFill>
+              </a:rPr>
+              <a:t>• Continuous Post-Complaint Monitoring: </a:t>
+            </a:r>
+            <a:r>
+              <a:rPr sz="1000">
+                <a:solidFill>
+                  <a:srgbClr val="0F172A"/>
+                </a:solidFill>
+              </a:rPr>
+              <a:t>Proactively monitors crime victims (SC/ST PoA Act 1989 / NHAA 14566) across investigation, court trial, compensation, and rehabilitation phases rather than waiting for crisis requests.</a:t>
+            </a:r>
+          </a:p>
+          <a:p>
+            <a:pPr>
+              <a:spcAft>
+                <a:spcPts val="250"/>
+              </a:spcAft>
+            </a:pPr>
+            <a:r>
+              <a:rPr b="1" sz="1050">
+                <a:solidFill>
+                  <a:srgbClr val="0D5050"/>
+                </a:solidFill>
+              </a:rPr>
+              <a:t>• Multichannel Interaction Hub: </a:t>
+            </a:r>
+            <a:r>
+              <a:rPr sz="1000">
+                <a:solidFill>
+                  <a:srgbClr val="0F172A"/>
+                </a:solidFill>
+              </a:rPr>
+              <a:t>Periodic check-ins via IVRS 14566 calls, Chatbot, SMS, Mobile App, and Web Portal with digital OTP consent and end-to-end AES-256 encryption.</a:t>
+            </a:r>
+          </a:p>
+          <a:p>
+            <a:pPr>
+              <a:spcAft>
+                <a:spcPts val="250"/>
+              </a:spcAft>
+            </a:pPr>
+            <a:r>
+              <a:rPr b="1" sz="1050">
+                <a:solidFill>
+                  <a:srgbClr val="0D5050"/>
+                </a:solidFill>
+              </a:rPr>
+              <a:t>• Dual-Risk Assessment Engine: </a:t>
+            </a:r>
+            <a:r>
+              <a:rPr sz="1000">
+                <a:solidFill>
+                  <a:srgbClr val="0F172A"/>
+                </a:solidFill>
+              </a:rPr>
+              <a:t>1) Immediate Physical Threat Check: Screens for active intimidation language. 2) Dynamic Distress Score (DDS 0–100): Multi-signal mathematical metric (DDS = w1*E + w2*V + w3*B + w4*H + w5*C + w6*T).</a:t>
+            </a:r>
+          </a:p>
+          <a:p>
+            <a:pPr>
+              <a:spcAft>
+                <a:spcPts val="250"/>
+              </a:spcAft>
+            </a:pPr>
+            <a:r>
+              <a:rPr b="1" sz="1050">
+                <a:solidFill>
+                  <a:srgbClr val="0D5050"/>
+                </a:solidFill>
+              </a:rPr>
+              <a:t>• 72-Hour Longitudinal Crisis Forecasting: </a:t>
+            </a:r>
+            <a:r>
+              <a:rPr sz="1000">
+                <a:solidFill>
+                  <a:srgbClr val="0F172A"/>
+                </a:solidFill>
+              </a:rPr>
+              <a:t>Calculates distress velocity (dDDS/dt) over past 7 days to predict psychological crisis 72 hours before escalation occurs.</a:t>
+            </a:r>
+          </a:p>
+          <a:p>
+            <a:pPr>
+              <a:spcAft>
+                <a:spcPts val="250"/>
+              </a:spcAft>
+            </a:pPr>
+            <a:r>
+              <a:rPr b="1" sz="1050">
+                <a:solidFill>
+                  <a:srgbClr val="0D5050"/>
+                </a:solidFill>
+              </a:rPr>
+              <a:t>• 3-Tier Risk Bands &amp; Action Matrix: </a:t>
+            </a:r>
+            <a:r>
+              <a:rPr sz="1000">
+                <a:solidFill>
+                  <a:srgbClr val="0F172A"/>
+                </a:solidFill>
+              </a:rPr>
+              <a:t>🟢 Green/Yellow (0–30): Routine wellness check-ins &amp; self-help tools. 🟠 Orange (31–60): Focused check-ins &amp; scheduled tele-counselling. ⭕ Red (61–100): Real-time alert to District Magistrate (DM) / SP dashboard, witness protection &amp; crisis team dispatch.</a:t>
+            </a:r>
+          </a:p>
+        </p:txBody>
+      </p:sp>
+      <p:sp>
+        <p:nvSpPr>
+          <p:cNvPr id="15363" name="Rounded Rectangle 15362"/>
+          <p:cNvSpPr/>
+          <p:nvPr/>
+        </p:nvSpPr>
+        <p:spPr>
+          <a:xfrm>
+            <a:off x="365760" y="4343400"/>
+            <a:ext cx="2697480" cy="1783080"/>
+          </a:xfrm>
+          <a:prstGeom prst="roundRect">
+            <a:avLst/>
+          </a:prstGeom>
+          <a:solidFill>
+            <a:srgbClr val="F5F8FA"/>
+          </a:solidFill>
+          <a:ln w="19050">
+            <a:solidFill>
+              <a:srgbClr val="0D5050"/>
+            </a:solidFill>
+          </a:ln>
+        </p:spPr>
+        <p:style>
+          <a:lnRef idx="1">
+            <a:schemeClr val="accent1"/>
+          </a:lnRef>
+          <a:fillRef idx="3">
+            <a:schemeClr val="accent1"/>
+          </a:fillRef>
+          <a:effectRef idx="2">
+            <a:schemeClr val="accent1"/>
+          </a:effectRef>
+          <a:fontRef idx="minor">
+            <a:schemeClr val="lt1"/>
+          </a:fontRef>
+        </p:style>
+        <p:txBody>
+          <a:bodyPr rtlCol="0" anchor="ctr" wrap="square" lIns="73152" rIns="73152" tIns="73152" bIns="73152"/>
+          <a:lstStyle/>
+          <a:p>
+            <a:pPr algn="ctr">
+              <a:spcAft>
+                <a:spcPts val="400"/>
+              </a:spcAft>
+              <a:defRPr b="1" sz="1100">
+                <a:solidFill>
+                  <a:srgbClr val="0D5050"/>
+                </a:solidFill>
+              </a:defRPr>
+            </a:pPr>
+            <a:r>
+              <a:t>Multichannel Ingestion (14566)</a:t>
+            </a:r>
+          </a:p>
+          <a:p>
+            <a:pPr>
+              <a:defRPr sz="950">
+                <a:solidFill>
+                  <a:srgbClr val="0F172A"/>
+                </a:solidFill>
+              </a:defRPr>
+            </a:pPr>
+            <a:r>
+              <a:t>IVRS 14566, Chatbot, SMS, Web &amp; Mobile App with OTP verification &amp; DPDP consent.</a:t>
+            </a:r>
+          </a:p>
+        </p:txBody>
+      </p:sp>
+      <p:sp>
+        <p:nvSpPr>
+          <p:cNvPr id="15364" name="Rounded Rectangle 15363"/>
+          <p:cNvSpPr/>
+          <p:nvPr/>
+        </p:nvSpPr>
+        <p:spPr>
+          <a:xfrm>
+            <a:off x="3246120" y="4343400"/>
+            <a:ext cx="2697480" cy="1783080"/>
+          </a:xfrm>
+          <a:prstGeom prst="roundRect">
+            <a:avLst/>
+          </a:prstGeom>
+          <a:solidFill>
+            <a:srgbClr val="F5F8FA"/>
+          </a:solidFill>
+          <a:ln w="19050">
+            <a:solidFill>
+              <a:srgbClr val="1A7A7A"/>
+            </a:solidFill>
+          </a:ln>
+        </p:spPr>
+        <p:style>
+          <a:lnRef idx="1">
+            <a:schemeClr val="accent1"/>
+          </a:lnRef>
+          <a:fillRef idx="3">
+            <a:schemeClr val="accent1"/>
+          </a:fillRef>
+          <a:effectRef idx="2">
+            <a:schemeClr val="accent1"/>
+          </a:effectRef>
+          <a:fontRef idx="minor">
+            <a:schemeClr val="lt1"/>
+          </a:fontRef>
+        </p:style>
+        <p:txBody>
+          <a:bodyPr rtlCol="0" anchor="ctr" wrap="square" lIns="73152" rIns="73152" tIns="73152" bIns="73152"/>
+          <a:lstStyle/>
+          <a:p>
+            <a:pPr algn="ctr">
+              <a:spcAft>
+                <a:spcPts val="400"/>
+              </a:spcAft>
+              <a:defRPr b="1" sz="1100">
+                <a:solidFill>
+                  <a:srgbClr val="1A7A7A"/>
+                </a:solidFill>
+              </a:defRPr>
+            </a:pPr>
+            <a:r>
+              <a:t>Emotion Wheel &amp; Voice AI</a:t>
+            </a:r>
+          </a:p>
+          <a:p>
+            <a:pPr>
+              <a:defRPr sz="950">
+                <a:solidFill>
+                  <a:srgbClr val="0F172A"/>
+                </a:solidFill>
+              </a:defRPr>
+            </a:pPr>
+            <a:r>
+              <a:t>Granular Plutchik emotion wheel for non-verbal input + vocal jitter &amp; pitch tremor analysis.</a:t>
+            </a:r>
+          </a:p>
+        </p:txBody>
+      </p:sp>
+      <p:sp>
+        <p:nvSpPr>
+          <p:cNvPr id="15365" name="Rounded Rectangle 15364"/>
+          <p:cNvSpPr/>
+          <p:nvPr/>
+        </p:nvSpPr>
+        <p:spPr>
+          <a:xfrm>
+            <a:off x="6126480" y="4343400"/>
+            <a:ext cx="2697480" cy="1783080"/>
+          </a:xfrm>
+          <a:prstGeom prst="roundRect">
+            <a:avLst/>
+          </a:prstGeom>
+          <a:solidFill>
+            <a:srgbClr val="F5F8FA"/>
+          </a:solidFill>
+          <a:ln w="19050">
+            <a:solidFill>
+              <a:srgbClr val="108C5A"/>
+            </a:solidFill>
+          </a:ln>
+        </p:spPr>
+        <p:style>
+          <a:lnRef idx="1">
+            <a:schemeClr val="accent1"/>
+          </a:lnRef>
+          <a:fillRef idx="3">
+            <a:schemeClr val="accent1"/>
+          </a:fillRef>
+          <a:effectRef idx="2">
+            <a:schemeClr val="accent1"/>
+          </a:effectRef>
+          <a:fontRef idx="minor">
+            <a:schemeClr val="lt1"/>
+          </a:fontRef>
+        </p:style>
+        <p:txBody>
+          <a:bodyPr rtlCol="0" anchor="ctr" wrap="square" lIns="73152" rIns="73152" tIns="73152" bIns="73152"/>
+          <a:lstStyle/>
+          <a:p>
+            <a:pPr algn="ctr">
+              <a:spcAft>
+                <a:spcPts val="400"/>
+              </a:spcAft>
+              <a:defRPr b="1" sz="1100">
+                <a:solidFill>
+                  <a:srgbClr val="108C5A"/>
+                </a:solidFill>
+              </a:defRPr>
+            </a:pPr>
+            <a:r>
+              <a:t>Calm Space &amp; Silent Mode</a:t>
+            </a:r>
+          </a:p>
+          <a:p>
+            <a:pPr>
+              <a:defRPr sz="950">
+                <a:solidFill>
+                  <a:srgbClr val="0F172A"/>
+                </a:solidFill>
+              </a:defRPr>
+            </a:pPr>
+            <a:r>
+              <a:t>Box Breathing (4-4-4-4), 5-4-3-2-1 Grounding, Ambient Audio + Silent Mode posture tracking.</a:t>
+            </a:r>
+          </a:p>
+        </p:txBody>
+      </p:sp>
+      <p:sp>
+        <p:nvSpPr>
+          <p:cNvPr id="15366" name="Rounded Rectangle 15365"/>
+          <p:cNvSpPr/>
+          <p:nvPr/>
+        </p:nvSpPr>
+        <p:spPr>
+          <a:xfrm>
+            <a:off x="9006840" y="4343400"/>
+            <a:ext cx="2697480" cy="1783080"/>
+          </a:xfrm>
+          <a:prstGeom prst="roundRect">
+            <a:avLst/>
+          </a:prstGeom>
+          <a:solidFill>
+            <a:srgbClr val="F5F8FA"/>
+          </a:solidFill>
+          <a:ln w="19050">
+            <a:solidFill>
+              <a:srgbClr val="0F172A"/>
+            </a:solidFill>
+          </a:ln>
+        </p:spPr>
+        <p:style>
+          <a:lnRef idx="1">
+            <a:schemeClr val="accent1"/>
+          </a:lnRef>
+          <a:fillRef idx="3">
+            <a:schemeClr val="accent1"/>
+          </a:fillRef>
+          <a:effectRef idx="2">
+            <a:schemeClr val="accent1"/>
+          </a:effectRef>
+          <a:fontRef idx="minor">
+            <a:schemeClr val="lt1"/>
+          </a:fontRef>
+        </p:style>
+        <p:txBody>
+          <a:bodyPr rtlCol="0" anchor="ctr" wrap="square" lIns="73152" rIns="73152" tIns="73152" bIns="73152"/>
+          <a:lstStyle/>
+          <a:p>
+            <a:pPr algn="ctr">
+              <a:spcAft>
+                <a:spcPts val="400"/>
+              </a:spcAft>
+              <a:defRPr b="1" sz="1100">
+                <a:solidFill>
+                  <a:srgbClr val="0F172A"/>
+                </a:solidFill>
+              </a:defRPr>
+            </a:pPr>
+            <a:r>
+              <a:t>4 Role-Based Logins</a:t>
+            </a:r>
+          </a:p>
+          <a:p>
+            <a:pPr>
+              <a:defRPr sz="950">
+                <a:solidFill>
+                  <a:srgbClr val="0F172A"/>
+                </a:solidFill>
+              </a:defRPr>
+            </a:pPr>
+            <a:r>
+              <a:t>1. Victim / Witness Portal</a:t>
+            </a:r>
+            <a:br/>
+            <a:r>
+              <a:t>2. Field Officer App</a:t>
+            </a:r>
+            <a:br/>
+            <a:r>
+              <a:t>3. DM / SP Dashboard</a:t>
+            </a:r>
+            <a:br/>
+            <a:r>
+              <a:t>4. National MoSJE Admin</a:t>
+            </a:r>
+          </a:p>
+        </p:txBody>
+      </p:sp>
     </p:spTree>
   </p:cSld>
   <p:clrMapOvr>
@@ -6260,118 +6762,6 @@
       </p:sp>
       <p:sp>
         <p:nvSpPr>
-          <p:cNvPr id="17410" name="TextBox 8"/>
-          <p:cNvSpPr txBox="1">
-            <a:spLocks noChangeArrowheads="1"/>
-          </p:cNvSpPr>
-          <p:nvPr/>
-        </p:nvSpPr>
-        <p:spPr bwMode="auto">
-          <a:xfrm>
-            <a:off x="609600" y="2533653"/>
-            <a:ext cx="9385300" cy="1815882"/>
-          </a:xfrm>
-          <a:prstGeom prst="rect">
-            <a:avLst/>
-          </a:prstGeom>
-          <a:noFill/>
-          <a:ln w="9525">
-            <a:noFill/>
-            <a:miter lim="800000"/>
-            <a:headEnd/>
-            <a:tailEnd/>
-          </a:ln>
-        </p:spPr>
-        <p:txBody>
-          <a:bodyPr wrap="square">
-            <a:spAutoFit/>
-          </a:bodyPr>
-          <a:lstStyle/>
-          <a:p>
-            <a:pPr marL="342900" indent="-342900" algn="just">
-              <a:buFont typeface="Arial" panose="020B0604020202020204" pitchFamily="34" charset="0"/>
-              <a:buChar char="•"/>
-            </a:pPr>
-          </a:p>
-          <a:p>
-            <a:pPr>
-              <a:spcAft>
-                <a:spcPts val="600"/>
-              </a:spcAft>
-              <a:defRPr sz="1200">
-                <a:solidFill>
-                  <a:srgbClr val="1E293B"/>
-                </a:solidFill>
-              </a:defRPr>
-            </a:pPr>
-            <a:r>
-              <a:t>• Multimodal Data Analysis Engine: NLP Sentiment &amp; Emotion AI (Transformer BERT for fear valence &amp; threat keywords 'dhamki', 'withdraw', 'court'), Vocal Acoustic Prosody (pitch tremor Hz, jitter %, pause duration), and Behavioral Check-in Gaps.</a:t>
-            </a:r>
-          </a:p>
-          <a:p>
-            <a:pPr>
-              <a:spcAft>
-                <a:spcPts val="600"/>
-              </a:spcAft>
-              <a:defRPr sz="1200">
-                <a:solidFill>
-                  <a:srgbClr val="1E293B"/>
-                </a:solidFill>
-              </a:defRPr>
-            </a:pPr>
-            <a:r>
-              <a:t>• Mathematical Dynamic Distress Scoring (DDS): DDS = 0.25*E + 0.20*V + 0.15*B + 0.15*H + 0.10*C + 0.15*T (Emotion, Voice Stress, Behavior, Historical Trend, Case Factors, Threat Language).</a:t>
-            </a:r>
-          </a:p>
-          <a:p>
-            <a:pPr>
-              <a:spcAft>
-                <a:spcPts val="600"/>
-              </a:spcAft>
-              <a:defRPr sz="1200">
-                <a:solidFill>
-                  <a:srgbClr val="1E293B"/>
-                </a:solidFill>
-              </a:defRPr>
-            </a:pPr>
-            <a:r>
-              <a:t>• Longitudinal Trend &amp; 72h Forecasting: Calculates distress velocity (dDDS/dt) over past 7 days to predict psychological crisis 72 hours before escalation occurs.</a:t>
-            </a:r>
-          </a:p>
-          <a:p>
-            <a:pPr>
-              <a:spcAft>
-                <a:spcPts val="600"/>
-              </a:spcAft>
-              <a:defRPr sz="1200">
-                <a:solidFill>
-                  <a:srgbClr val="1E293B"/>
-                </a:solidFill>
-              </a:defRPr>
-            </a:pPr>
-            <a:r>
-              <a:t>• Explainable AI (SHAP / LIME XAI): Provides exact point attributions (+21 threat, +18 fear, +14 velocity, +12 missed check-ins, +9 voice stress) for transparent, audit-ready officer decisions.</a:t>
-            </a:r>
-          </a:p>
-          <a:p>
-            <a:pPr>
-              <a:spcAft>
-                <a:spcPts val="600"/>
-              </a:spcAft>
-              <a:defRPr sz="1200">
-                <a:solidFill>
-                  <a:srgbClr val="1E293B"/>
-                </a:solidFill>
-              </a:defRPr>
-            </a:pPr>
-            <a:r>
-              <a:t>• Technology Stack &amp; Architecture: Python FastAPI backend, PyTorch, React + Vite frontend, SQLite/PostgreSQL, Web Speech API, DPDP 2023 Security.</a:t>
-            </a:r>
-          </a:p>
-        </p:txBody>
-      </p:sp>
-      <p:sp>
-        <p:nvSpPr>
           <p:cNvPr id="6" name="Slide Number Placeholder 5"/>
           <p:cNvSpPr>
             <a:spLocks noGrp="1"/>
@@ -6483,11 +6873,16 @@
           <a:bodyPr rtlCol="0" anchor="ctr"/>
           <a:lstStyle/>
           <a:p>
-            <a:pPr algn="ctr"/>
+            <a:pPr>
+              <a:defRPr b="1" sz="1400">
+                <a:solidFill>
+                  <a:srgbClr val="0D5050"/>
+                </a:solidFill>
+              </a:defRPr>
+            </a:pPr>
             <a:r>
               <a:t>DEKO</a:t>
             </a:r>
-            <a:endParaRPr lang="en-IN" dirty="0"/>
           </a:p>
         </p:txBody>
       </p:sp>
@@ -6521,6 +6916,702 @@
           </a:prstGeom>
         </p:spPr>
       </p:pic>
+      <p:sp>
+        <p:nvSpPr>
+          <p:cNvPr id="17410" name="Rounded Rectangle 17409"/>
+          <p:cNvSpPr/>
+          <p:nvPr/>
+        </p:nvSpPr>
+        <p:spPr>
+          <a:xfrm>
+            <a:off x="365760" y="1188720"/>
+            <a:ext cx="5120640" cy="4937760"/>
+          </a:xfrm>
+          <a:prstGeom prst="roundRect">
+            <a:avLst/>
+          </a:prstGeom>
+          <a:solidFill>
+            <a:srgbClr val="F5F8FA"/>
+          </a:solidFill>
+          <a:ln w="19050">
+            <a:solidFill>
+              <a:srgbClr val="1A7A7A"/>
+            </a:solidFill>
+          </a:ln>
+        </p:spPr>
+        <p:style>
+          <a:lnRef idx="1">
+            <a:schemeClr val="accent1"/>
+          </a:lnRef>
+          <a:fillRef idx="3">
+            <a:schemeClr val="accent1"/>
+          </a:fillRef>
+          <a:effectRef idx="2">
+            <a:schemeClr val="accent1"/>
+          </a:effectRef>
+          <a:fontRef idx="minor">
+            <a:schemeClr val="lt1"/>
+          </a:fontRef>
+        </p:style>
+        <p:txBody>
+          <a:bodyPr rtlCol="0" anchor="ctr" wrap="square" lIns="73152" rIns="73152" tIns="73152" bIns="73152"/>
+          <a:lstStyle/>
+          <a:p>
+            <a:pPr algn="ctr">
+              <a:spcAft>
+                <a:spcPts val="600"/>
+              </a:spcAft>
+              <a:defRPr b="1" sz="1300">
+                <a:solidFill>
+                  <a:srgbClr val="0D5050"/>
+                </a:solidFill>
+              </a:defRPr>
+            </a:pPr>
+            <a:r>
+              <a:t>Idea / Approach Flowchart</a:t>
+            </a:r>
+          </a:p>
+          <a:p>
+            <a:pPr>
+              <a:spcAft>
+                <a:spcPts val="400"/>
+              </a:spcAft>
+            </a:pPr>
+            <a:r>
+              <a:rPr b="1" sz="950">
+                <a:solidFill>
+                  <a:srgbClr val="0D5050"/>
+                </a:solidFill>
+              </a:rPr>
+              <a:t>Step 1: Onboarding &amp; Multichannel Ingestion: </a:t>
+            </a:r>
+            <a:r>
+              <a:rPr sz="900">
+                <a:solidFill>
+                  <a:srgbClr val="0F172A"/>
+                </a:solidFill>
+              </a:rPr>
+              <a:t>Victim complaint registered -&gt; OTP verification -&gt; Digital consent (DPDP Act 2023) -&gt; Scheduled outreach via IVRS 14566, Chatbot, SMS, or Mobile App.</a:t>
+            </a:r>
+          </a:p>
+          <a:p>
+            <a:pPr>
+              <a:spcAft>
+                <a:spcPts val="400"/>
+              </a:spcAft>
+            </a:pPr>
+            <a:r>
+              <a:rPr b="1" sz="950">
+                <a:solidFill>
+                  <a:srgbClr val="0D5050"/>
+                </a:solidFill>
+              </a:rPr>
+              <a:t>Step 2: Multimodal AI Signal Ingestion: </a:t>
+            </a:r>
+            <a:r>
+              <a:rPr sz="900">
+                <a:solidFill>
+                  <a:srgbClr val="0F172A"/>
+                </a:solidFill>
+              </a:rPr>
+              <a:t>NLP Text Sentiment (Transformer BERT for fear valence &amp; threat keywords 'dhamki', 'withdraw'), Vocal Acoustic Prosody (pitch tremor Hz, jitter %, pause duration), and Behavioral Check-in Gaps.</a:t>
+            </a:r>
+          </a:p>
+          <a:p>
+            <a:pPr>
+              <a:spcAft>
+                <a:spcPts val="400"/>
+              </a:spcAft>
+            </a:pPr>
+            <a:r>
+              <a:rPr b="1" sz="950">
+                <a:solidFill>
+                  <a:srgbClr val="0D5050"/>
+                </a:solidFill>
+              </a:rPr>
+              <a:t>Step 3: Dynamic Distress Scoring (0–100): </a:t>
+            </a:r>
+            <a:r>
+              <a:rPr sz="900">
+                <a:solidFill>
+                  <a:srgbClr val="0F172A"/>
+                </a:solidFill>
+              </a:rPr>
+              <a:t>Calculates continuous formula: DDS = 0.25*E + 0.20*V + 0.15*B + 0.15*H + 0.10*C + 0.15*T.</a:t>
+            </a:r>
+          </a:p>
+          <a:p>
+            <a:pPr>
+              <a:spcAft>
+                <a:spcPts val="400"/>
+              </a:spcAft>
+            </a:pPr>
+            <a:r>
+              <a:rPr b="1" sz="950">
+                <a:solidFill>
+                  <a:srgbClr val="0D5050"/>
+                </a:solidFill>
+              </a:rPr>
+              <a:t>Step 4: 72h Crisis Forecast &amp; Explainable AI (XAI): </a:t>
+            </a:r>
+            <a:r>
+              <a:rPr sz="900">
+                <a:solidFill>
+                  <a:srgbClr val="0F172A"/>
+                </a:solidFill>
+              </a:rPr>
+              <a:t>Time-series trend velocity (dDDS/dt) predicts crisis 72h prior. SHAP/LIME point attributions (+21 threat, +18 fear, +14 velocity, +12 missed check-ins, +9 voice stress).</a:t>
+            </a:r>
+          </a:p>
+          <a:p>
+            <a:pPr>
+              <a:spcAft>
+                <a:spcPts val="400"/>
+              </a:spcAft>
+            </a:pPr>
+            <a:r>
+              <a:rPr b="1" sz="950">
+                <a:solidFill>
+                  <a:srgbClr val="0D5050"/>
+                </a:solidFill>
+              </a:rPr>
+              <a:t>Step 5: Automated 3-Tier Risk Action Dispatch: </a:t>
+            </a:r>
+            <a:r>
+              <a:rPr sz="900">
+                <a:solidFill>
+                  <a:srgbClr val="0F172A"/>
+                </a:solidFill>
+              </a:rPr>
+              <a:t>🟢 0–30: Self-help grounding audio &amp; rights pamphlets | 🟠 31–60: Focused check-ins &amp; tele-counselling | ⭕ 61–100: Real-time alert to DM / SP dashboard, police protection &amp; crisis team dispatch.</a:t>
+            </a:r>
+          </a:p>
+        </p:txBody>
+      </p:sp>
+      <p:graphicFrame>
+        <p:nvGraphicFramePr>
+          <p:cNvPr id="17411" name="Table 17410"/>
+          <p:cNvGraphicFramePr>
+            <a:graphicFrameLocks noGrp="1"/>
+          </p:cNvGraphicFramePr>
+          <p:nvPr/>
+        </p:nvGraphicFramePr>
+        <p:xfrm>
+          <a:off x="5669280" y="1188720"/>
+          <a:ext cx="6035040" cy="4937760"/>
+        </p:xfrm>
+        <a:graphic>
+          <a:graphicData uri="http://schemas.openxmlformats.org/drawingml/2006/table">
+            <a:tbl>
+              <a:tblPr firstRow="1" bandRow="1">
+                <a:tableStyleId>{5C22544A-7EE6-4342-B048-85BDC9FD1C3A}</a:tableStyleId>
+              </a:tblPr>
+              <a:tblGrid>
+                <a:gridCol w="1463040"/>
+                <a:gridCol w="2103120"/>
+                <a:gridCol w="2468880"/>
+              </a:tblGrid>
+              <a:tr h="705394">
+                <a:tc>
+                  <a:txBody>
+                    <a:bodyPr wrap="square" lIns="73152" rIns="73152" tIns="73152" bIns="73152"/>
+                    <a:lstStyle/>
+                    <a:p>
+                      <a:pPr>
+                        <a:defRPr b="1" sz="1000">
+                          <a:solidFill>
+                            <a:srgbClr val="FFFFFF"/>
+                          </a:solidFill>
+                        </a:defRPr>
+                      </a:pPr>
+                      <a:r>
+                        <a:t>Parameter</a:t>
+                      </a:r>
+                    </a:p>
+                  </a:txBody>
+                  <a:tcPr anchor="ctr">
+                    <a:solidFill>
+                      <a:srgbClr val="0D5050"/>
+                    </a:solidFill>
+                  </a:tcPr>
+                </a:tc>
+                <a:tc>
+                  <a:txBody>
+                    <a:bodyPr wrap="square" lIns="73152" rIns="73152" tIns="73152" bIns="73152"/>
+                    <a:lstStyle/>
+                    <a:p>
+                      <a:pPr>
+                        <a:defRPr b="1" sz="1000">
+                          <a:solidFill>
+                            <a:srgbClr val="FFFFFF"/>
+                          </a:solidFill>
+                        </a:defRPr>
+                      </a:pPr>
+                      <a:r>
+                        <a:t>Existing Manual System</a:t>
+                      </a:r>
+                    </a:p>
+                  </a:txBody>
+                  <a:tcPr anchor="ctr">
+                    <a:solidFill>
+                      <a:srgbClr val="0D5050"/>
+                    </a:solidFill>
+                  </a:tcPr>
+                </a:tc>
+                <a:tc>
+                  <a:txBody>
+                    <a:bodyPr wrap="square" lIns="73152" rIns="73152" tIns="73152" bIns="73152"/>
+                    <a:lstStyle/>
+                    <a:p>
+                      <a:pPr>
+                        <a:defRPr b="1" sz="1000">
+                          <a:solidFill>
+                            <a:srgbClr val="FFFFFF"/>
+                          </a:solidFill>
+                        </a:defRPr>
+                      </a:pPr>
+                      <a:r>
+                        <a:t>Proposed KEFI AI Platform</a:t>
+                      </a:r>
+                    </a:p>
+                  </a:txBody>
+                  <a:tcPr anchor="ctr">
+                    <a:solidFill>
+                      <a:srgbClr val="0D5050"/>
+                    </a:solidFill>
+                  </a:tcPr>
+                </a:tc>
+              </a:tr>
+              <a:tr h="705394">
+                <a:tc>
+                  <a:txBody>
+                    <a:bodyPr wrap="square" lIns="73152" rIns="73152" tIns="73152" bIns="73152"/>
+                    <a:lstStyle/>
+                    <a:p>
+                      <a:pPr>
+                        <a:defRPr sz="850" b="1">
+                          <a:solidFill>
+                            <a:srgbClr val="0F172A"/>
+                          </a:solidFill>
+                        </a:defRPr>
+                      </a:pPr>
+                      <a:r>
+                        <a:t>Monitoring Model</a:t>
+                      </a:r>
+                    </a:p>
+                  </a:txBody>
+                  <a:tcPr anchor="ctr">
+                    <a:solidFill>
+                      <a:srgbClr val="FFFFFF"/>
+                    </a:solidFill>
+                  </a:tcPr>
+                </a:tc>
+                <a:tc>
+                  <a:txBody>
+                    <a:bodyPr wrap="square" lIns="73152" rIns="73152" tIns="73152" bIns="73152"/>
+                    <a:lstStyle/>
+                    <a:p>
+                      <a:pPr>
+                        <a:defRPr sz="850">
+                          <a:solidFill>
+                            <a:srgbClr val="0F172A"/>
+                          </a:solidFill>
+                        </a:defRPr>
+                      </a:pPr>
+                      <a:r>
+                        <a:t>Passive (Victim must ask for help during severe crisis)</a:t>
+                      </a:r>
+                    </a:p>
+                  </a:txBody>
+                  <a:tcPr anchor="ctr">
+                    <a:solidFill>
+                      <a:srgbClr val="FFFFFF"/>
+                    </a:solidFill>
+                  </a:tcPr>
+                </a:tc>
+                <a:tc>
+                  <a:txBody>
+                    <a:bodyPr wrap="square" lIns="73152" rIns="73152" tIns="73152" bIns="73152"/>
+                    <a:lstStyle/>
+                    <a:p>
+                      <a:pPr>
+                        <a:defRPr sz="850" b="1">
+                          <a:solidFill>
+                            <a:srgbClr val="0D5050"/>
+                          </a:solidFill>
+                        </a:defRPr>
+                      </a:pPr>
+                      <a:r>
+                        <a:t>Proactive &amp; Continuous (Automated scheduled check-ins)</a:t>
+                      </a:r>
+                    </a:p>
+                  </a:txBody>
+                  <a:tcPr anchor="ctr">
+                    <a:solidFill>
+                      <a:srgbClr val="FFFFFF"/>
+                    </a:solidFill>
+                  </a:tcPr>
+                </a:tc>
+              </a:tr>
+              <a:tr h="705394">
+                <a:tc>
+                  <a:txBody>
+                    <a:bodyPr wrap="square" lIns="73152" rIns="73152" tIns="73152" bIns="73152"/>
+                    <a:lstStyle/>
+                    <a:p>
+                      <a:pPr>
+                        <a:defRPr sz="850" b="1">
+                          <a:solidFill>
+                            <a:srgbClr val="0F172A"/>
+                          </a:solidFill>
+                        </a:defRPr>
+                      </a:pPr>
+                      <a:r>
+                        <a:t>Distress Assessment</a:t>
+                      </a:r>
+                    </a:p>
+                  </a:txBody>
+                  <a:tcPr anchor="ctr">
+                    <a:solidFill>
+                      <a:srgbClr val="F5F8FA"/>
+                    </a:solidFill>
+                  </a:tcPr>
+                </a:tc>
+                <a:tc>
+                  <a:txBody>
+                    <a:bodyPr wrap="square" lIns="73152" rIns="73152" tIns="73152" bIns="73152"/>
+                    <a:lstStyle/>
+                    <a:p>
+                      <a:pPr>
+                        <a:defRPr sz="850">
+                          <a:solidFill>
+                            <a:srgbClr val="0F172A"/>
+                          </a:solidFill>
+                        </a:defRPr>
+                      </a:pPr>
+                      <a:r>
+                        <a:t>Subjective / Nil post-complaint registration</a:t>
+                      </a:r>
+                    </a:p>
+                  </a:txBody>
+                  <a:tcPr anchor="ctr">
+                    <a:solidFill>
+                      <a:srgbClr val="F5F8FA"/>
+                    </a:solidFill>
+                  </a:tcPr>
+                </a:tc>
+                <a:tc>
+                  <a:txBody>
+                    <a:bodyPr wrap="square" lIns="73152" rIns="73152" tIns="73152" bIns="73152"/>
+                    <a:lstStyle/>
+                    <a:p>
+                      <a:pPr>
+                        <a:defRPr sz="850" b="1">
+                          <a:solidFill>
+                            <a:srgbClr val="0D5050"/>
+                          </a:solidFill>
+                        </a:defRPr>
+                      </a:pPr>
+                      <a:r>
+                        <a:t>Mathematical Dynamic Distress Score (DDS: 0–100)</a:t>
+                      </a:r>
+                    </a:p>
+                  </a:txBody>
+                  <a:tcPr anchor="ctr">
+                    <a:solidFill>
+                      <a:srgbClr val="F5F8FA"/>
+                    </a:solidFill>
+                  </a:tcPr>
+                </a:tc>
+              </a:tr>
+              <a:tr h="705394">
+                <a:tc>
+                  <a:txBody>
+                    <a:bodyPr wrap="square" lIns="73152" rIns="73152" tIns="73152" bIns="73152"/>
+                    <a:lstStyle/>
+                    <a:p>
+                      <a:pPr>
+                        <a:defRPr sz="850" b="1">
+                          <a:solidFill>
+                            <a:srgbClr val="0F172A"/>
+                          </a:solidFill>
+                        </a:defRPr>
+                      </a:pPr>
+                      <a:r>
+                        <a:t>Data Modalities</a:t>
+                      </a:r>
+                    </a:p>
+                  </a:txBody>
+                  <a:tcPr anchor="ctr">
+                    <a:solidFill>
+                      <a:srgbClr val="FFFFFF"/>
+                    </a:solidFill>
+                  </a:tcPr>
+                </a:tc>
+                <a:tc>
+                  <a:txBody>
+                    <a:bodyPr wrap="square" lIns="73152" rIns="73152" tIns="73152" bIns="73152"/>
+                    <a:lstStyle/>
+                    <a:p>
+                      <a:pPr>
+                        <a:defRPr sz="850">
+                          <a:solidFill>
+                            <a:srgbClr val="0F172A"/>
+                          </a:solidFill>
+                        </a:defRPr>
+                      </a:pPr>
+                      <a:r>
+                        <a:t>Manual paper records / infrequent police visits</a:t>
+                      </a:r>
+                    </a:p>
+                  </a:txBody>
+                  <a:tcPr anchor="ctr">
+                    <a:solidFill>
+                      <a:srgbClr val="FFFFFF"/>
+                    </a:solidFill>
+                  </a:tcPr>
+                </a:tc>
+                <a:tc>
+                  <a:txBody>
+                    <a:bodyPr wrap="square" lIns="73152" rIns="73152" tIns="73152" bIns="73152"/>
+                    <a:lstStyle/>
+                    <a:p>
+                      <a:pPr>
+                        <a:defRPr sz="850" b="1">
+                          <a:solidFill>
+                            <a:srgbClr val="0D5050"/>
+                          </a:solidFill>
+                        </a:defRPr>
+                      </a:pPr>
+                      <a:r>
+                        <a:t>Multimodal (Text NLP, Acoustic Prosody, Behavior, Threat Keywords)</a:t>
+                      </a:r>
+                    </a:p>
+                  </a:txBody>
+                  <a:tcPr anchor="ctr">
+                    <a:solidFill>
+                      <a:srgbClr val="FFFFFF"/>
+                    </a:solidFill>
+                  </a:tcPr>
+                </a:tc>
+              </a:tr>
+              <a:tr h="705394">
+                <a:tc>
+                  <a:txBody>
+                    <a:bodyPr wrap="square" lIns="73152" rIns="73152" tIns="73152" bIns="73152"/>
+                    <a:lstStyle/>
+                    <a:p>
+                      <a:pPr>
+                        <a:defRPr sz="850" b="1">
+                          <a:solidFill>
+                            <a:srgbClr val="0F172A"/>
+                          </a:solidFill>
+                        </a:defRPr>
+                      </a:pPr>
+                      <a:r>
+                        <a:t>Early Warning</a:t>
+                      </a:r>
+                    </a:p>
+                  </a:txBody>
+                  <a:tcPr anchor="ctr">
+                    <a:solidFill>
+                      <a:srgbClr val="F5F8FA"/>
+                    </a:solidFill>
+                  </a:tcPr>
+                </a:tc>
+                <a:tc>
+                  <a:txBody>
+                    <a:bodyPr wrap="square" lIns="73152" rIns="73152" tIns="73152" bIns="73152"/>
+                    <a:lstStyle/>
+                    <a:p>
+                      <a:pPr>
+                        <a:defRPr sz="850">
+                          <a:solidFill>
+                            <a:srgbClr val="0F172A"/>
+                          </a:solidFill>
+                        </a:defRPr>
+                      </a:pPr>
+                      <a:r>
+                        <a:t>Reactive (Intervention only after suicide / harm)</a:t>
+                      </a:r>
+                    </a:p>
+                  </a:txBody>
+                  <a:tcPr anchor="ctr">
+                    <a:solidFill>
+                      <a:srgbClr val="F5F8FA"/>
+                    </a:solidFill>
+                  </a:tcPr>
+                </a:tc>
+                <a:tc>
+                  <a:txBody>
+                    <a:bodyPr wrap="square" lIns="73152" rIns="73152" tIns="73152" bIns="73152"/>
+                    <a:lstStyle/>
+                    <a:p>
+                      <a:pPr>
+                        <a:defRPr sz="850" b="1">
+                          <a:solidFill>
+                            <a:srgbClr val="0D5050"/>
+                          </a:solidFill>
+                        </a:defRPr>
+                      </a:pPr>
+                      <a:r>
+                        <a:t>72-Hour Predictive Trend Velocity Forecasting (dDDS/dt)</a:t>
+                      </a:r>
+                    </a:p>
+                  </a:txBody>
+                  <a:tcPr anchor="ctr">
+                    <a:solidFill>
+                      <a:srgbClr val="F5F8FA"/>
+                    </a:solidFill>
+                  </a:tcPr>
+                </a:tc>
+              </a:tr>
+              <a:tr h="705394">
+                <a:tc>
+                  <a:txBody>
+                    <a:bodyPr wrap="square" lIns="73152" rIns="73152" tIns="73152" bIns="73152"/>
+                    <a:lstStyle/>
+                    <a:p>
+                      <a:pPr>
+                        <a:defRPr sz="850" b="1">
+                          <a:solidFill>
+                            <a:srgbClr val="0F172A"/>
+                          </a:solidFill>
+                        </a:defRPr>
+                      </a:pPr>
+                      <a:r>
+                        <a:t>Decision Transparency</a:t>
+                      </a:r>
+                    </a:p>
+                  </a:txBody>
+                  <a:tcPr anchor="ctr">
+                    <a:solidFill>
+                      <a:srgbClr val="FFFFFF"/>
+                    </a:solidFill>
+                  </a:tcPr>
+                </a:tc>
+                <a:tc>
+                  <a:txBody>
+                    <a:bodyPr wrap="square" lIns="73152" rIns="73152" tIns="73152" bIns="73152"/>
+                    <a:lstStyle/>
+                    <a:p>
+                      <a:pPr>
+                        <a:defRPr sz="850">
+                          <a:solidFill>
+                            <a:srgbClr val="0F172A"/>
+                          </a:solidFill>
+                        </a:defRPr>
+                      </a:pPr>
+                      <a:r>
+                        <a:t>Black-box officer discretion</a:t>
+                      </a:r>
+                    </a:p>
+                  </a:txBody>
+                  <a:tcPr anchor="ctr">
+                    <a:solidFill>
+                      <a:srgbClr val="FFFFFF"/>
+                    </a:solidFill>
+                  </a:tcPr>
+                </a:tc>
+                <a:tc>
+                  <a:txBody>
+                    <a:bodyPr wrap="square" lIns="73152" rIns="73152" tIns="73152" bIns="73152"/>
+                    <a:lstStyle/>
+                    <a:p>
+                      <a:pPr>
+                        <a:defRPr sz="850" b="1">
+                          <a:solidFill>
+                            <a:srgbClr val="0D5050"/>
+                          </a:solidFill>
+                        </a:defRPr>
+                      </a:pPr>
+                      <a:r>
+                        <a:t>Explainable AI (SHAP/LIME) with exact numerical point additions</a:t>
+                      </a:r>
+                    </a:p>
+                  </a:txBody>
+                  <a:tcPr anchor="ctr">
+                    <a:solidFill>
+                      <a:srgbClr val="FFFFFF"/>
+                    </a:solidFill>
+                  </a:tcPr>
+                </a:tc>
+              </a:tr>
+              <a:tr h="705396">
+                <a:tc>
+                  <a:txBody>
+                    <a:bodyPr wrap="square" lIns="73152" rIns="73152" tIns="73152" bIns="73152"/>
+                    <a:lstStyle/>
+                    <a:p>
+                      <a:pPr>
+                        <a:defRPr sz="850" b="1">
+                          <a:solidFill>
+                            <a:srgbClr val="0F172A"/>
+                          </a:solidFill>
+                        </a:defRPr>
+                      </a:pPr>
+                      <a:r>
+                        <a:t>Governance Visibility</a:t>
+                      </a:r>
+                    </a:p>
+                  </a:txBody>
+                  <a:tcPr anchor="ctr">
+                    <a:solidFill>
+                      <a:srgbClr val="F5F8FA"/>
+                    </a:solidFill>
+                  </a:tcPr>
+                </a:tc>
+                <a:tc>
+                  <a:txBody>
+                    <a:bodyPr wrap="square" lIns="73152" rIns="73152" tIns="73152" bIns="73152"/>
+                    <a:lstStyle/>
+                    <a:p>
+                      <a:pPr>
+                        <a:defRPr sz="850">
+                          <a:solidFill>
+                            <a:srgbClr val="0F172A"/>
+                          </a:solidFill>
+                        </a:defRPr>
+                      </a:pPr>
+                      <a:r>
+                        <a:t>Disconnected district registers</a:t>
+                      </a:r>
+                    </a:p>
+                  </a:txBody>
+                  <a:tcPr anchor="ctr">
+                    <a:solidFill>
+                      <a:srgbClr val="F5F8FA"/>
+                    </a:solidFill>
+                  </a:tcPr>
+                </a:tc>
+                <a:tc>
+                  <a:txBody>
+                    <a:bodyPr wrap="square" lIns="73152" rIns="73152" tIns="73152" bIns="73152"/>
+                    <a:lstStyle/>
+                    <a:p>
+                      <a:pPr>
+                        <a:defRPr sz="850" b="1">
+                          <a:solidFill>
+                            <a:srgbClr val="0D5050"/>
+                          </a:solidFill>
+                        </a:defRPr>
+                      </a:pPr>
+                      <a:r>
+                        <a:t>Real-Time District (DM/SP) &amp; National MoSJE Dashboards</a:t>
+                      </a:r>
+                    </a:p>
+                  </a:txBody>
+                  <a:tcPr anchor="ctr">
+                    <a:solidFill>
+                      <a:srgbClr val="F5F8FA"/>
+                    </a:solidFill>
+                  </a:tcPr>
+                </a:tc>
+              </a:tr>
+            </a:tbl>
+          </a:graphicData>
+        </a:graphic>
+      </p:graphicFrame>
     </p:spTree>
   </p:cSld>
   <p:clrMapOvr>
@@ -6648,145 +7739,6 @@
                 <a:cs typeface="Times New Roman" panose="02020603050405020304" pitchFamily="18" charset="0"/>
               </a:rPr>
               <a:t>FEASIBILITY AND VIABILITY</a:t>
-            </a:r>
-          </a:p>
-        </p:txBody>
-      </p:sp>
-      <p:sp>
-        <p:nvSpPr>
-          <p:cNvPr id="17410" name="TextBox 8"/>
-          <p:cNvSpPr txBox="1">
-            <a:spLocks noChangeArrowheads="1"/>
-          </p:cNvSpPr>
-          <p:nvPr/>
-        </p:nvSpPr>
-        <p:spPr bwMode="auto">
-          <a:xfrm>
-            <a:off x="609600" y="2533653"/>
-            <a:ext cx="9385300" cy="1384995"/>
-          </a:xfrm>
-          <a:prstGeom prst="rect">
-            <a:avLst/>
-          </a:prstGeom>
-          <a:noFill/>
-          <a:ln w="9525">
-            <a:noFill/>
-            <a:miter lim="800000"/>
-            <a:headEnd/>
-            <a:tailEnd/>
-          </a:ln>
-        </p:spPr>
-        <p:txBody>
-          <a:bodyPr wrap="square">
-            <a:spAutoFit/>
-          </a:bodyPr>
-          <a:lstStyle/>
-          <a:p>
-            <a:pPr marL="342900" marR="0" lvl="0" indent="-342900" algn="just" defTabSz="457200" rtl="0" eaLnBrk="1" fontAlgn="base" latinLnBrk="0" hangingPunct="1">
-              <a:lnSpc>
-                <a:spcPct val="100000"/>
-              </a:lnSpc>
-              <a:spcBef>
-                <a:spcPct val="0"/>
-              </a:spcBef>
-              <a:spcAft>
-                <a:spcPct val="0"/>
-              </a:spcAft>
-              <a:buClrTx/>
-              <a:buSzTx/>
-              <a:buFont typeface="Arial" panose="020B0604020202020204" pitchFamily="34" charset="0"/>
-              <a:buChar char="•"/>
-              <a:tabLst/>
-              <a:defRPr/>
-            </a:pPr>
-            <a:endParaRPr kumimoji="0" lang="en-US" sz="2800" b="0" i="0" u="none" strike="noStrike" kern="1200" cap="none" spc="0" normalizeH="0" baseline="0" noProof="0" dirty="0">
-              <a:ln>
-                <a:noFill/>
-              </a:ln>
-              <a:solidFill>
-                <a:prstClr val="black"/>
-              </a:solidFill>
-              <a:effectLst/>
-              <a:uLnTx/>
-              <a:uFillTx/>
-              <a:latin typeface="Arial" pitchFamily="34" charset="0"/>
-              <a:ea typeface="ＭＳ Ｐゴシック" pitchFamily="1" charset="-128"/>
-              <a:cs typeface="Arial" pitchFamily="34" charset="0"/>
-            </a:endParaRPr>
-          </a:p>
-          <a:p>
-            <a:pPr>
-              <a:spcAft>
-                <a:spcPts val="600"/>
-              </a:spcAft>
-              <a:defRPr sz="1200">
-                <a:solidFill>
-                  <a:srgbClr val="1E293B"/>
-                </a:solidFill>
-              </a:defRPr>
-            </a:pPr>
-            <a:r>
-              <a:t>• Operational Feasibility: Integrates seamlessly with existing MoSJE National Helpline Against Atrocities (NHAA 14566), welfare officers, and police liaisons without overloading staff.</a:t>
-            </a:r>
-          </a:p>
-          <a:p>
-            <a:pPr>
-              <a:spcAft>
-                <a:spcPts val="600"/>
-              </a:spcAft>
-              <a:defRPr sz="1200">
-                <a:solidFill>
-                  <a:srgbClr val="1E293B"/>
-                </a:solidFill>
-              </a:defRPr>
-            </a:pPr>
-            <a:r>
-              <a:t>• Low-Bandwidth &amp; Offline Adaptability: Low Internet Mode allows offline grounding audio, low-data layout, and basic SMS fallback for remote rural atrocity victims.</a:t>
-            </a:r>
-          </a:p>
-          <a:p>
-            <a:pPr>
-              <a:spcAft>
-                <a:spcPts val="600"/>
-              </a:spcAft>
-              <a:defRPr sz="1200">
-                <a:solidFill>
-                  <a:srgbClr val="1E293B"/>
-                </a:solidFill>
-              </a:defRPr>
-            </a:pPr>
-            <a:r>
-              <a:t>• Risk 1: Alarm Fatigue &amp; False Positives: Mitigation: Dual-layer verification combining AI Distress Score with Field Welfare Officer ground observation notes.</a:t>
-            </a:r>
-          </a:p>
-          <a:p>
-            <a:pPr>
-              <a:spcAft>
-                <a:spcPts val="600"/>
-              </a:spcAft>
-              <a:defRPr sz="1200">
-                <a:solidFill>
-                  <a:srgbClr val="1E293B"/>
-                </a:solidFill>
-              </a:defRPr>
-            </a:pPr>
-            <a:r>
-              <a:t>• Risk 2: Data Privacy &amp; Security Concerns: Mitigation: Fully DPDP Act 2023 compliant with end-to-end AES-256 encryption, victim data consent management, and auto-purge options.</a:t>
-            </a:r>
-          </a:p>
-          <a:p>
-            <a:pPr>
-              <a:spcAft>
-                <a:spcPts val="600"/>
-              </a:spcAft>
-              <a:defRPr sz="1200">
-                <a:solidFill>
-                  <a:srgbClr val="1E293B"/>
-                </a:solidFill>
-              </a:defRPr>
-            </a:pPr>
-            <a:r>
-              <a:t>• Risk 3: Multilingual &amp; Literacy Barriers: Mitigation: Multilingual conversational AI supporting Tanglish, Tamil, Hindi, and English + Silent Mode body language &amp; posture detection.</a:t>
             </a:r>
           </a:p>
         </p:txBody>
@@ -6987,11 +7939,16 @@
           <a:bodyPr rtlCol="0" anchor="ctr"/>
           <a:lstStyle/>
           <a:p>
-            <a:pPr algn="ctr"/>
+            <a:pPr>
+              <a:defRPr b="1" sz="1400">
+                <a:solidFill>
+                  <a:srgbClr val="0D5050"/>
+                </a:solidFill>
+              </a:defRPr>
+            </a:pPr>
             <a:r>
               <a:t>DEKO</a:t>
             </a:r>
-            <a:endParaRPr lang="en-IN" dirty="0"/>
           </a:p>
         </p:txBody>
       </p:sp>
@@ -7025,6 +7982,441 @@
           </a:prstGeom>
         </p:spPr>
       </p:pic>
+      <p:sp>
+        <p:nvSpPr>
+          <p:cNvPr id="17410" name="Rounded Rectangle 17409"/>
+          <p:cNvSpPr/>
+          <p:nvPr/>
+        </p:nvSpPr>
+        <p:spPr>
+          <a:xfrm>
+            <a:off x="365760" y="1188720"/>
+            <a:ext cx="5303520" cy="2286000"/>
+          </a:xfrm>
+          <a:prstGeom prst="roundRect">
+            <a:avLst/>
+          </a:prstGeom>
+          <a:solidFill>
+            <a:srgbClr val="F5F8FA"/>
+          </a:solidFill>
+          <a:ln w="19050">
+            <a:solidFill>
+              <a:srgbClr val="1A7A7A"/>
+            </a:solidFill>
+          </a:ln>
+        </p:spPr>
+        <p:style>
+          <a:lnRef idx="1">
+            <a:schemeClr val="accent1"/>
+          </a:lnRef>
+          <a:fillRef idx="3">
+            <a:schemeClr val="accent1"/>
+          </a:fillRef>
+          <a:effectRef idx="2">
+            <a:schemeClr val="accent1"/>
+          </a:effectRef>
+          <a:fontRef idx="minor">
+            <a:schemeClr val="lt1"/>
+          </a:fontRef>
+        </p:style>
+        <p:txBody>
+          <a:bodyPr rtlCol="0" anchor="ctr" wrap="square" lIns="73152" rIns="73152" tIns="73152" bIns="73152"/>
+          <a:lstStyle/>
+          <a:p>
+            <a:pPr algn="ctr">
+              <a:spcAft>
+                <a:spcPts val="400"/>
+              </a:spcAft>
+              <a:defRPr b="1" sz="1200">
+                <a:solidFill>
+                  <a:srgbClr val="0D5050"/>
+                </a:solidFill>
+              </a:defRPr>
+            </a:pPr>
+            <a:r>
+              <a:t>Analysis of the Feasibility:</a:t>
+            </a:r>
+          </a:p>
+          <a:p>
+            <a:pPr>
+              <a:spcAft>
+                <a:spcPts val="250"/>
+              </a:spcAft>
+              <a:defRPr sz="900">
+                <a:solidFill>
+                  <a:srgbClr val="0F172A"/>
+                </a:solidFill>
+              </a:defRPr>
+            </a:pPr>
+            <a:r>
+              <a:t>• Seamless Operational Integration: Integrates directly with existing MoSJE National Helpline Against Atrocities (NHAA 14566), District Magistrates (DM), SPs, and welfare officers without adding administrative workload.</a:t>
+            </a:r>
+          </a:p>
+          <a:p>
+            <a:pPr>
+              <a:spcAft>
+                <a:spcPts val="250"/>
+              </a:spcAft>
+              <a:defRPr sz="900">
+                <a:solidFill>
+                  <a:srgbClr val="0F172A"/>
+                </a:solidFill>
+              </a:defRPr>
+            </a:pPr>
+            <a:r>
+              <a:t>• Hardware-Agnostic &amp; Scalable: Requires no costly wearable hardware. Operates via standard phone calls (IVRS), SMS, and web portal.</a:t>
+            </a:r>
+          </a:p>
+          <a:p>
+            <a:pPr>
+              <a:spcAft>
+                <a:spcPts val="250"/>
+              </a:spcAft>
+              <a:defRPr sz="900">
+                <a:solidFill>
+                  <a:srgbClr val="0F172A"/>
+                </a:solidFill>
+              </a:defRPr>
+            </a:pPr>
+            <a:r>
+              <a:t>• Low-Bandwidth Adaptability: Low Internet Mode allows offline grounding audio, low-data layout, and basic SMS fallback for remote rural atrocity victims.</a:t>
+            </a:r>
+          </a:p>
+        </p:txBody>
+      </p:sp>
+      <p:sp>
+        <p:nvSpPr>
+          <p:cNvPr id="17411" name="Rounded Rectangle 17410"/>
+          <p:cNvSpPr/>
+          <p:nvPr/>
+        </p:nvSpPr>
+        <p:spPr>
+          <a:xfrm>
+            <a:off x="365760" y="3657600"/>
+            <a:ext cx="5303520" cy="2468880"/>
+          </a:xfrm>
+          <a:prstGeom prst="roundRect">
+            <a:avLst/>
+          </a:prstGeom>
+          <a:solidFill>
+            <a:srgbClr val="F5F8FA"/>
+          </a:solidFill>
+          <a:ln w="19050">
+            <a:solidFill>
+              <a:srgbClr val="D97706"/>
+            </a:solidFill>
+          </a:ln>
+        </p:spPr>
+        <p:style>
+          <a:lnRef idx="1">
+            <a:schemeClr val="accent1"/>
+          </a:lnRef>
+          <a:fillRef idx="3">
+            <a:schemeClr val="accent1"/>
+          </a:fillRef>
+          <a:effectRef idx="2">
+            <a:schemeClr val="accent1"/>
+          </a:effectRef>
+          <a:fontRef idx="minor">
+            <a:schemeClr val="lt1"/>
+          </a:fontRef>
+        </p:style>
+        <p:txBody>
+          <a:bodyPr rtlCol="0" anchor="ctr" wrap="square" lIns="73152" rIns="73152" tIns="73152" bIns="73152"/>
+          <a:lstStyle/>
+          <a:p>
+            <a:pPr algn="ctr">
+              <a:spcAft>
+                <a:spcPts val="400"/>
+              </a:spcAft>
+              <a:defRPr b="1" sz="1200">
+                <a:solidFill>
+                  <a:srgbClr val="D97706"/>
+                </a:solidFill>
+              </a:defRPr>
+            </a:pPr>
+            <a:r>
+              <a:t>Potential Challenges &amp; Strategies for Overcoming:</a:t>
+            </a:r>
+          </a:p>
+          <a:p>
+            <a:pPr>
+              <a:defRPr b="1" sz="950">
+                <a:solidFill>
+                  <a:srgbClr val="0D5050"/>
+                </a:solidFill>
+              </a:defRPr>
+            </a:pPr>
+            <a:r>
+              <a:t>• Risk 1: Alarm Fatigue &amp; False Positives</a:t>
+            </a:r>
+          </a:p>
+          <a:p>
+            <a:pPr>
+              <a:spcAft>
+                <a:spcPts val="200"/>
+              </a:spcAft>
+              <a:defRPr sz="900">
+                <a:solidFill>
+                  <a:srgbClr val="0F172A"/>
+                </a:solidFill>
+              </a:defRPr>
+            </a:pPr>
+            <a:r>
+              <a:t>↳ Strategy: Dual-layer verification combining automated AI Distress Score with Field Welfare Officer ground observation notes.</a:t>
+            </a:r>
+          </a:p>
+          <a:p>
+            <a:pPr>
+              <a:defRPr b="1" sz="950">
+                <a:solidFill>
+                  <a:srgbClr val="0D5050"/>
+                </a:solidFill>
+              </a:defRPr>
+            </a:pPr>
+            <a:r>
+              <a:t>• Risk 2: Data Privacy &amp; Victim Security</a:t>
+            </a:r>
+          </a:p>
+          <a:p>
+            <a:pPr>
+              <a:spcAft>
+                <a:spcPts val="200"/>
+              </a:spcAft>
+              <a:defRPr sz="900">
+                <a:solidFill>
+                  <a:srgbClr val="0F172A"/>
+                </a:solidFill>
+              </a:defRPr>
+            </a:pPr>
+            <a:r>
+              <a:t>↳ Strategy: 100% DPDP Act 2023 compliant with end-to-end AES-256 encryption, OTP consent, and victim data purge controls.</a:t>
+            </a:r>
+          </a:p>
+          <a:p>
+            <a:pPr>
+              <a:defRPr b="1" sz="950">
+                <a:solidFill>
+                  <a:srgbClr val="0D5050"/>
+                </a:solidFill>
+              </a:defRPr>
+            </a:pPr>
+            <a:r>
+              <a:t>• Risk 3: Literacy &amp; Multilingual Barriers</a:t>
+            </a:r>
+          </a:p>
+          <a:p>
+            <a:pPr>
+              <a:spcAft>
+                <a:spcPts val="200"/>
+              </a:spcAft>
+              <a:defRPr sz="900">
+                <a:solidFill>
+                  <a:srgbClr val="0F172A"/>
+                </a:solidFill>
+              </a:defRPr>
+            </a:pPr>
+            <a:r>
+              <a:t>↳ Strategy: Multilingual conversational AI supporting Tanglish (தமிழ்-English), Tamil, Hindi, and English + Silent Mode non-verbal support.</a:t>
+            </a:r>
+          </a:p>
+        </p:txBody>
+      </p:sp>
+      <p:sp>
+        <p:nvSpPr>
+          <p:cNvPr id="17412" name="Rounded Rectangle 17411"/>
+          <p:cNvSpPr/>
+          <p:nvPr/>
+        </p:nvSpPr>
+        <p:spPr>
+          <a:xfrm>
+            <a:off x="5852160" y="1188720"/>
+            <a:ext cx="5852160" cy="4937760"/>
+          </a:xfrm>
+          <a:prstGeom prst="roundRect">
+            <a:avLst/>
+          </a:prstGeom>
+          <a:solidFill>
+            <a:srgbClr val="F5F8FA"/>
+          </a:solidFill>
+          <a:ln w="19050">
+            <a:solidFill>
+              <a:srgbClr val="1A7A7A"/>
+            </a:solidFill>
+          </a:ln>
+        </p:spPr>
+        <p:style>
+          <a:lnRef idx="1">
+            <a:schemeClr val="accent1"/>
+          </a:lnRef>
+          <a:fillRef idx="3">
+            <a:schemeClr val="accent1"/>
+          </a:fillRef>
+          <a:effectRef idx="2">
+            <a:schemeClr val="accent1"/>
+          </a:effectRef>
+          <a:fontRef idx="minor">
+            <a:schemeClr val="lt1"/>
+          </a:fontRef>
+        </p:style>
+        <p:txBody>
+          <a:bodyPr rtlCol="0" anchor="ctr" wrap="square" lIns="73152" rIns="73152" tIns="73152" bIns="73152"/>
+          <a:lstStyle/>
+          <a:p>
+            <a:pPr algn="ctr">
+              <a:spcAft>
+                <a:spcPts val="800"/>
+              </a:spcAft>
+              <a:defRPr b="1" sz="1300">
+                <a:solidFill>
+                  <a:srgbClr val="0D5050"/>
+                </a:solidFill>
+              </a:defRPr>
+            </a:pPr>
+            <a:r>
+              <a:t>TECHNOLOGICAL STACK:</a:t>
+            </a:r>
+          </a:p>
+          <a:p>
+            <a:pPr>
+              <a:spcAft>
+                <a:spcPts val="400"/>
+              </a:spcAft>
+            </a:pPr>
+            <a:r>
+              <a:rPr b="1" sz="1000">
+                <a:solidFill>
+                  <a:srgbClr val="0D5050"/>
+                </a:solidFill>
+              </a:rPr>
+              <a:t>• Frontend Architecture: </a:t>
+            </a:r>
+            <a:r>
+              <a:rPr sz="950">
+                <a:solidFill>
+                  <a:srgbClr val="0F172A"/>
+                </a:solidFill>
+              </a:rPr>
+              <a:t>React 18, Vite 8, Vanilla CSS &amp; Tailwind, Web Speech API (Voice Recognition &amp; TTS), face-api.js for Silent Vision Detection.</a:t>
+            </a:r>
+          </a:p>
+          <a:p>
+            <a:pPr>
+              <a:spcAft>
+                <a:spcPts val="400"/>
+              </a:spcAft>
+            </a:pPr>
+            <a:r>
+              <a:rPr b="1" sz="1000">
+                <a:solidFill>
+                  <a:srgbClr val="0D5050"/>
+                </a:solidFill>
+              </a:rPr>
+              <a:t>• Backend Microservices: </a:t>
+            </a:r>
+            <a:r>
+              <a:rPr sz="950">
+                <a:solidFill>
+                  <a:srgbClr val="0F172A"/>
+                </a:solidFill>
+              </a:rPr>
+              <a:t>Python 3.12, FastAPI, Uvicorn ASGI Server, RESTful API architecture with &lt;250ms response latency.</a:t>
+            </a:r>
+          </a:p>
+          <a:p>
+            <a:pPr>
+              <a:spcAft>
+                <a:spcPts val="400"/>
+              </a:spcAft>
+            </a:pPr>
+            <a:r>
+              <a:rPr b="1" sz="1000">
+                <a:solidFill>
+                  <a:srgbClr val="0D5050"/>
+                </a:solidFill>
+              </a:rPr>
+              <a:t>• AI / NLP &amp; Acoustic Models: </a:t>
+            </a:r>
+            <a:r>
+              <a:rPr sz="950">
+                <a:solidFill>
+                  <a:srgbClr val="0F172A"/>
+                </a:solidFill>
+              </a:rPr>
+              <a:t>Hugging Face Transformers (BERT Sentiment for fear valence), Acoustic Speech Prosody Analyzer (Pitch Tremor Hz, Jitter %, Pause Gaps), Cognitive Distortion Mapper.</a:t>
+            </a:r>
+          </a:p>
+          <a:p>
+            <a:pPr>
+              <a:spcAft>
+                <a:spcPts val="400"/>
+              </a:spcAft>
+            </a:pPr>
+            <a:r>
+              <a:rPr b="1" sz="1000">
+                <a:solidFill>
+                  <a:srgbClr val="0D5050"/>
+                </a:solidFill>
+              </a:rPr>
+              <a:t>• Predictive &amp; Explainable AI (XAI): </a:t>
+            </a:r>
+            <a:r>
+              <a:rPr sz="950">
+                <a:solidFill>
+                  <a:srgbClr val="0F172A"/>
+                </a:solidFill>
+              </a:rPr>
+              <a:t>Time-Series Distress Velocity Forecasting (dDDS/dt for 72h crisis prediction), SHAP &amp; LIME Hybrid Point Attribution Engine (+21, +18, +14, +12, +9).</a:t>
+            </a:r>
+          </a:p>
+          <a:p>
+            <a:pPr>
+              <a:spcAft>
+                <a:spcPts val="400"/>
+              </a:spcAft>
+            </a:pPr>
+            <a:r>
+              <a:rPr b="1" sz="1000">
+                <a:solidFill>
+                  <a:srgbClr val="0D5050"/>
+                </a:solidFill>
+              </a:rPr>
+              <a:t>• Database &amp; Cloud Infrastructure: </a:t>
+            </a:r>
+            <a:r>
+              <a:rPr sz="950">
+                <a:solidFill>
+                  <a:srgbClr val="0F172A"/>
+                </a:solidFill>
+              </a:rPr>
+              <a:t>SQLite / PostgreSQL with SQLAlchemy ORM, Redis for session caching, Docker containerization for MeghRaj / NIC Cloud deployment.</a:t>
+            </a:r>
+          </a:p>
+          <a:p>
+            <a:pPr>
+              <a:spcAft>
+                <a:spcPts val="400"/>
+              </a:spcAft>
+            </a:pPr>
+            <a:r>
+              <a:rPr b="1" sz="1000">
+                <a:solidFill>
+                  <a:srgbClr val="0D5050"/>
+                </a:solidFill>
+              </a:rPr>
+              <a:t>• Security &amp; Governance: </a:t>
+            </a:r>
+            <a:r>
+              <a:rPr sz="950">
+                <a:solidFill>
+                  <a:srgbClr val="0F172A"/>
+                </a:solidFill>
+              </a:rPr>
+              <a:t>Digital Personal Data Protection (DPDP) Act 2023 Compliance, AES-256 Data Encryption at rest &amp; in transit, SHA-256 OTP Authentication, Role-Based Access Control (RBAC).</a:t>
+            </a:r>
+          </a:p>
+        </p:txBody>
+      </p:sp>
     </p:spTree>
     <p:extLst>
       <p:ext uri="{BB962C8B-B14F-4D97-AF65-F5344CB8AC3E}">
@@ -7157,131 +8549,6 @@
                 <a:cs typeface="Times New Roman" panose="02020603050405020304" pitchFamily="18" charset="0"/>
               </a:rPr>
               <a:t>IMPACT AND BENEFITS</a:t>
-            </a:r>
-          </a:p>
-        </p:txBody>
-      </p:sp>
-      <p:sp>
-        <p:nvSpPr>
-          <p:cNvPr id="17410" name="TextBox 8"/>
-          <p:cNvSpPr txBox="1">
-            <a:spLocks noChangeArrowheads="1"/>
-          </p:cNvSpPr>
-          <p:nvPr/>
-        </p:nvSpPr>
-        <p:spPr bwMode="auto">
-          <a:xfrm>
-            <a:off x="609600" y="2533653"/>
-            <a:ext cx="9385300" cy="1384995"/>
-          </a:xfrm>
-          <a:prstGeom prst="rect">
-            <a:avLst/>
-          </a:prstGeom>
-          <a:noFill/>
-          <a:ln w="9525">
-            <a:noFill/>
-            <a:miter lim="800000"/>
-            <a:headEnd/>
-            <a:tailEnd/>
-          </a:ln>
-        </p:spPr>
-        <p:txBody>
-          <a:bodyPr wrap="square">
-            <a:spAutoFit/>
-          </a:bodyPr>
-          <a:lstStyle/>
-          <a:p>
-            <a:pPr marL="342900" marR="0" lvl="0" indent="-342900" algn="just" defTabSz="457200" rtl="0" eaLnBrk="1" fontAlgn="base" latinLnBrk="0" hangingPunct="1">
-              <a:lnSpc>
-                <a:spcPct val="100000"/>
-              </a:lnSpc>
-              <a:spcBef>
-                <a:spcPct val="0"/>
-              </a:spcBef>
-              <a:spcAft>
-                <a:spcPct val="0"/>
-              </a:spcAft>
-              <a:buClrTx/>
-              <a:buSzTx/>
-              <a:buFont typeface="Arial" panose="020B0604020202020204" pitchFamily="34" charset="0"/>
-              <a:buChar char="•"/>
-              <a:tabLst/>
-              <a:defRPr/>
-            </a:pPr>
-          </a:p>
-          <a:p>
-            <a:pPr>
-              <a:spcAft>
-                <a:spcPts val="600"/>
-              </a:spcAft>
-              <a:defRPr sz="1200">
-                <a:solidFill>
-                  <a:srgbClr val="1E293B"/>
-                </a:solidFill>
-              </a:defRPr>
-            </a:pPr>
-            <a:r>
-              <a:t>• Target Beneficiaries (SC/ST PoA Act 1989): Victims of atrocity (rape/gang rape, grievous hurt, murder, arson), witnesses facing trial intimidation, and affected families under SC/ST (Prevention of Atrocities) Act 1989.</a:t>
-            </a:r>
-          </a:p>
-          <a:p>
-            <a:pPr>
-              <a:spcAft>
-                <a:spcPts val="600"/>
-              </a:spcAft>
-              <a:defRPr sz="1200">
-                <a:solidFill>
-                  <a:srgbClr val="1E293B"/>
-                </a:solidFill>
-              </a:defRPr>
-            </a:pPr>
-            <a:r>
-              <a:t>• Early Mental Crisis Prevention: Identifies escalating psychological distress before severe trauma, relapse, or self-harm occurs, providing timely crisis tele-counselling.</a:t>
-            </a:r>
-          </a:p>
-          <a:p>
-            <a:pPr>
-              <a:spcAft>
-                <a:spcPts val="600"/>
-              </a:spcAft>
-              <a:defRPr sz="1200">
-                <a:solidFill>
-                  <a:srgbClr val="1E293B"/>
-                </a:solidFill>
-              </a:defRPr>
-            </a:pPr>
-            <a:r>
-              <a:t>• Victim Empowerment &amp; Self-Help: Provides 5-4-3-2-1 grounding, box breathing, legal rights pamphlets, and transparent feedback loops.</a:t>
-            </a:r>
-          </a:p>
-          <a:p>
-            <a:pPr>
-              <a:spcAft>
-                <a:spcPts val="600"/>
-              </a:spcAft>
-              <a:defRPr sz="1200">
-                <a:solidFill>
-                  <a:srgbClr val="1E293B"/>
-                </a:solidFill>
-              </a:defRPr>
-            </a:pPr>
-            <a:r>
-              <a:t>• Strengthened Justice System Trust: Proactive state care rebuilds victim confidence, reducing witness retraction and trial dropouts.</a:t>
-            </a:r>
-          </a:p>
-          <a:p>
-            <a:pPr>
-              <a:spcAft>
-                <a:spcPts val="600"/>
-              </a:spcAft>
-              <a:defRPr sz="1200">
-                <a:solidFill>
-                  <a:srgbClr val="1E293B"/>
-                </a:solidFill>
-              </a:defRPr>
-            </a:pPr>
-            <a:r>
-              <a:t>• Evidence-Based Governance: Real-time district, state, and national MoSJE dashboards for District Magistrates (DM) and Superintendents of Police (SP) to prioritize high-risk cases.</a:t>
             </a:r>
           </a:p>
         </p:txBody>
@@ -7482,11 +8749,16 @@
           <a:bodyPr rtlCol="0" anchor="ctr"/>
           <a:lstStyle/>
           <a:p>
-            <a:pPr algn="ctr"/>
+            <a:pPr>
+              <a:defRPr b="1" sz="1400">
+                <a:solidFill>
+                  <a:srgbClr val="0D5050"/>
+                </a:solidFill>
+              </a:defRPr>
+            </a:pPr>
             <a:r>
               <a:t>DEKO</a:t>
             </a:r>
-            <a:endParaRPr lang="en-IN" dirty="0"/>
           </a:p>
         </p:txBody>
       </p:sp>
@@ -7520,6 +8792,603 @@
           </a:prstGeom>
         </p:spPr>
       </p:pic>
+      <p:sp>
+        <p:nvSpPr>
+          <p:cNvPr id="17410" name="Rounded Rectangle 17409"/>
+          <p:cNvSpPr/>
+          <p:nvPr/>
+        </p:nvSpPr>
+        <p:spPr>
+          <a:xfrm>
+            <a:off x="365760" y="1188720"/>
+            <a:ext cx="2697480" cy="1371600"/>
+          </a:xfrm>
+          <a:prstGeom prst="roundRect">
+            <a:avLst/>
+          </a:prstGeom>
+          <a:solidFill>
+            <a:srgbClr val="F5F8FA"/>
+          </a:solidFill>
+          <a:ln w="19050">
+            <a:solidFill>
+              <a:srgbClr val="0D5050"/>
+            </a:solidFill>
+          </a:ln>
+        </p:spPr>
+        <p:style>
+          <a:lnRef idx="1">
+            <a:schemeClr val="accent1"/>
+          </a:lnRef>
+          <a:fillRef idx="3">
+            <a:schemeClr val="accent1"/>
+          </a:fillRef>
+          <a:effectRef idx="2">
+            <a:schemeClr val="accent1"/>
+          </a:effectRef>
+          <a:fontRef idx="minor">
+            <a:schemeClr val="lt1"/>
+          </a:fontRef>
+        </p:style>
+        <p:txBody>
+          <a:bodyPr rtlCol="0" anchor="ctr" wrap="square" lIns="73152" rIns="73152" tIns="73152" bIns="73152"/>
+          <a:lstStyle/>
+          <a:p>
+            <a:pPr algn="ctr">
+              <a:spcAft>
+                <a:spcPts val="200"/>
+              </a:spcAft>
+              <a:defRPr b="1" sz="1050">
+                <a:solidFill>
+                  <a:srgbClr val="0D5050"/>
+                </a:solidFill>
+              </a:defRPr>
+            </a:pPr>
+            <a:r>
+              <a:t>Victim Portal &amp; Emotion Wheel</a:t>
+            </a:r>
+          </a:p>
+          <a:p>
+            <a:pPr>
+              <a:defRPr sz="900">
+                <a:solidFill>
+                  <a:srgbClr val="0F172A"/>
+                </a:solidFill>
+              </a:defRPr>
+            </a:pPr>
+            <a:r>
+              <a:t>Granular emotion wheel, daily mood log &amp; instant calming support.</a:t>
+            </a:r>
+          </a:p>
+        </p:txBody>
+      </p:sp>
+      <p:sp>
+        <p:nvSpPr>
+          <p:cNvPr id="17411" name="Rounded Rectangle 17410"/>
+          <p:cNvSpPr/>
+          <p:nvPr/>
+        </p:nvSpPr>
+        <p:spPr>
+          <a:xfrm>
+            <a:off x="3246120" y="1188720"/>
+            <a:ext cx="2697480" cy="1371600"/>
+          </a:xfrm>
+          <a:prstGeom prst="roundRect">
+            <a:avLst/>
+          </a:prstGeom>
+          <a:solidFill>
+            <a:srgbClr val="F5F8FA"/>
+          </a:solidFill>
+          <a:ln w="19050">
+            <a:solidFill>
+              <a:srgbClr val="1A7A7A"/>
+            </a:solidFill>
+          </a:ln>
+        </p:spPr>
+        <p:style>
+          <a:lnRef idx="1">
+            <a:schemeClr val="accent1"/>
+          </a:lnRef>
+          <a:fillRef idx="3">
+            <a:schemeClr val="accent1"/>
+          </a:fillRef>
+          <a:effectRef idx="2">
+            <a:schemeClr val="accent1"/>
+          </a:effectRef>
+          <a:fontRef idx="minor">
+            <a:schemeClr val="lt1"/>
+          </a:fontRef>
+        </p:style>
+        <p:txBody>
+          <a:bodyPr rtlCol="0" anchor="ctr" wrap="square" lIns="73152" rIns="73152" tIns="73152" bIns="73152"/>
+          <a:lstStyle/>
+          <a:p>
+            <a:pPr algn="ctr">
+              <a:spcAft>
+                <a:spcPts val="200"/>
+              </a:spcAft>
+              <a:defRPr b="1" sz="1050">
+                <a:solidFill>
+                  <a:srgbClr val="1A7A7A"/>
+                </a:solidFill>
+              </a:defRPr>
+            </a:pPr>
+            <a:r>
+              <a:t>Dynamic Distress (0-100) &amp; Trend</a:t>
+            </a:r>
+          </a:p>
+          <a:p>
+            <a:pPr>
+              <a:defRPr sz="900">
+                <a:solidFill>
+                  <a:srgbClr val="0F172A"/>
+                </a:solidFill>
+              </a:defRPr>
+            </a:pPr>
+            <a:r>
+              <a:t>Continuous score tracking with 72h crisis velocity forecasting.</a:t>
+            </a:r>
+          </a:p>
+        </p:txBody>
+      </p:sp>
+      <p:sp>
+        <p:nvSpPr>
+          <p:cNvPr id="17412" name="Rounded Rectangle 17411"/>
+          <p:cNvSpPr/>
+          <p:nvPr/>
+        </p:nvSpPr>
+        <p:spPr>
+          <a:xfrm>
+            <a:off x="6126480" y="1188720"/>
+            <a:ext cx="2697480" cy="1371600"/>
+          </a:xfrm>
+          <a:prstGeom prst="roundRect">
+            <a:avLst/>
+          </a:prstGeom>
+          <a:solidFill>
+            <a:srgbClr val="F5F8FA"/>
+          </a:solidFill>
+          <a:ln w="19050">
+            <a:solidFill>
+              <a:srgbClr val="DC2626"/>
+            </a:solidFill>
+          </a:ln>
+        </p:spPr>
+        <p:style>
+          <a:lnRef idx="1">
+            <a:schemeClr val="accent1"/>
+          </a:lnRef>
+          <a:fillRef idx="3">
+            <a:schemeClr val="accent1"/>
+          </a:fillRef>
+          <a:effectRef idx="2">
+            <a:schemeClr val="accent1"/>
+          </a:effectRef>
+          <a:fontRef idx="minor">
+            <a:schemeClr val="lt1"/>
+          </a:fontRef>
+        </p:style>
+        <p:txBody>
+          <a:bodyPr rtlCol="0" anchor="ctr" wrap="square" lIns="73152" rIns="73152" tIns="73152" bIns="73152"/>
+          <a:lstStyle/>
+          <a:p>
+            <a:pPr algn="ctr">
+              <a:spcAft>
+                <a:spcPts val="200"/>
+              </a:spcAft>
+              <a:defRPr b="1" sz="1050">
+                <a:solidFill>
+                  <a:srgbClr val="DC2626"/>
+                </a:solidFill>
+              </a:defRPr>
+            </a:pPr>
+            <a:r>
+              <a:t>DM / SP Alert &amp; Intervention</a:t>
+            </a:r>
+          </a:p>
+          <a:p>
+            <a:pPr>
+              <a:defRPr sz="900">
+                <a:solidFill>
+                  <a:srgbClr val="0F172A"/>
+                </a:solidFill>
+              </a:defRPr>
+            </a:pPr>
+            <a:r>
+              <a:t>Real-time red-band crisis alerts, witness protection &amp; officer dispatch.</a:t>
+            </a:r>
+          </a:p>
+        </p:txBody>
+      </p:sp>
+      <p:sp>
+        <p:nvSpPr>
+          <p:cNvPr id="17413" name="Rounded Rectangle 17412"/>
+          <p:cNvSpPr/>
+          <p:nvPr/>
+        </p:nvSpPr>
+        <p:spPr>
+          <a:xfrm>
+            <a:off x="9006840" y="1188720"/>
+            <a:ext cx="2697480" cy="1371600"/>
+          </a:xfrm>
+          <a:prstGeom prst="roundRect">
+            <a:avLst/>
+          </a:prstGeom>
+          <a:solidFill>
+            <a:srgbClr val="F5F8FA"/>
+          </a:solidFill>
+          <a:ln w="19050">
+            <a:solidFill>
+              <a:srgbClr val="108C5A"/>
+            </a:solidFill>
+          </a:ln>
+        </p:spPr>
+        <p:style>
+          <a:lnRef idx="1">
+            <a:schemeClr val="accent1"/>
+          </a:lnRef>
+          <a:fillRef idx="3">
+            <a:schemeClr val="accent1"/>
+          </a:fillRef>
+          <a:effectRef idx="2">
+            <a:schemeClr val="accent1"/>
+          </a:effectRef>
+          <a:fontRef idx="minor">
+            <a:schemeClr val="lt1"/>
+          </a:fontRef>
+        </p:style>
+        <p:txBody>
+          <a:bodyPr rtlCol="0" anchor="ctr" wrap="square" lIns="73152" rIns="73152" tIns="73152" bIns="73152"/>
+          <a:lstStyle/>
+          <a:p>
+            <a:pPr algn="ctr">
+              <a:spcAft>
+                <a:spcPts val="200"/>
+              </a:spcAft>
+              <a:defRPr b="1" sz="1050">
+                <a:solidFill>
+                  <a:srgbClr val="108C5A"/>
+                </a:solidFill>
+              </a:defRPr>
+            </a:pPr>
+            <a:r>
+              <a:t>Calm Space &amp; Silent Sanctuary</a:t>
+            </a:r>
+          </a:p>
+          <a:p>
+            <a:pPr>
+              <a:defRPr sz="900">
+                <a:solidFill>
+                  <a:srgbClr val="0F172A"/>
+                </a:solidFill>
+              </a:defRPr>
+            </a:pPr>
+            <a:r>
+              <a:t>Box Breathing (4-4-4-4), 5-4-3-2-1 Grounding &amp; ambient audio.</a:t>
+            </a:r>
+          </a:p>
+        </p:txBody>
+      </p:sp>
+      <p:sp>
+        <p:nvSpPr>
+          <p:cNvPr id="17414" name="Rounded Rectangle 17413"/>
+          <p:cNvSpPr/>
+          <p:nvPr/>
+        </p:nvSpPr>
+        <p:spPr>
+          <a:xfrm>
+            <a:off x="365760" y="2743200"/>
+            <a:ext cx="5394960" cy="3383280"/>
+          </a:xfrm>
+          <a:prstGeom prst="roundRect">
+            <a:avLst/>
+          </a:prstGeom>
+          <a:solidFill>
+            <a:srgbClr val="F5F8FA"/>
+          </a:solidFill>
+          <a:ln w="19050">
+            <a:solidFill>
+              <a:srgbClr val="1A7A7A"/>
+            </a:solidFill>
+          </a:ln>
+        </p:spPr>
+        <p:style>
+          <a:lnRef idx="1">
+            <a:schemeClr val="accent1"/>
+          </a:lnRef>
+          <a:fillRef idx="3">
+            <a:schemeClr val="accent1"/>
+          </a:fillRef>
+          <a:effectRef idx="2">
+            <a:schemeClr val="accent1"/>
+          </a:effectRef>
+          <a:fontRef idx="minor">
+            <a:schemeClr val="lt1"/>
+          </a:fontRef>
+        </p:style>
+        <p:txBody>
+          <a:bodyPr rtlCol="0" anchor="ctr" wrap="square" lIns="73152" rIns="73152" tIns="73152" bIns="73152"/>
+          <a:lstStyle/>
+          <a:p>
+            <a:pPr algn="ctr">
+              <a:spcAft>
+                <a:spcPts val="400"/>
+              </a:spcAft>
+              <a:defRPr b="1" sz="1200">
+                <a:solidFill>
+                  <a:srgbClr val="0D5050"/>
+                </a:solidFill>
+              </a:defRPr>
+            </a:pPr>
+            <a:r>
+              <a:t>Potential Impact on the Target Audience:</a:t>
+            </a:r>
+          </a:p>
+          <a:p>
+            <a:pPr>
+              <a:spcAft>
+                <a:spcPts val="300"/>
+              </a:spcAft>
+            </a:pPr>
+            <a:r>
+              <a:rPr b="1" sz="950">
+                <a:solidFill>
+                  <a:srgbClr val="0D5050"/>
+                </a:solidFill>
+              </a:rPr>
+              <a:t>• Victims of Rape, Gang Rape &amp; Grievous Hurt: </a:t>
+            </a:r>
+            <a:r>
+              <a:rPr sz="900">
+                <a:solidFill>
+                  <a:srgbClr val="0F172A"/>
+                </a:solidFill>
+              </a:rPr>
+              <a:t>Continuous psychological care reduces trauma isolation and prevents severe PTSD, self-harm, and psychological collapse.</a:t>
+            </a:r>
+          </a:p>
+          <a:p>
+            <a:pPr>
+              <a:spcAft>
+                <a:spcPts val="300"/>
+              </a:spcAft>
+            </a:pPr>
+            <a:r>
+              <a:rPr b="1" sz="950">
+                <a:solidFill>
+                  <a:srgbClr val="0D5050"/>
+                </a:solidFill>
+              </a:rPr>
+              <a:t>• Witnesses Facing Intimidation &amp; Threats: </a:t>
+            </a:r>
+            <a:r>
+              <a:rPr sz="900">
+                <a:solidFill>
+                  <a:srgbClr val="0F172A"/>
+                </a:solidFill>
+              </a:rPr>
+              <a:t>Proactive screening of coercion keywords and immediate witness protection prevent trial retraction and intimidation.</a:t>
+            </a:r>
+          </a:p>
+          <a:p>
+            <a:pPr>
+              <a:spcAft>
+                <a:spcPts val="300"/>
+              </a:spcAft>
+            </a:pPr>
+            <a:r>
+              <a:rPr b="1" sz="950">
+                <a:solidFill>
+                  <a:srgbClr val="0D5050"/>
+                </a:solidFill>
+              </a:rPr>
+              <a:t>• Families Affected by Caste-Based Violence: </a:t>
+            </a:r>
+            <a:r>
+              <a:rPr sz="900">
+                <a:solidFill>
+                  <a:srgbClr val="0F172A"/>
+                </a:solidFill>
+              </a:rPr>
+              <a:t>Systematic monitoring of relief distribution, legal aid progress, and rehabilitation milestones under SC/ST PoA Act.</a:t>
+            </a:r>
+          </a:p>
+          <a:p>
+            <a:pPr>
+              <a:spcAft>
+                <a:spcPts val="300"/>
+              </a:spcAft>
+            </a:pPr>
+            <a:r>
+              <a:rPr b="1" sz="950">
+                <a:solidFill>
+                  <a:srgbClr val="0D5050"/>
+                </a:solidFill>
+              </a:rPr>
+              <a:t>• Victim Empowerment &amp; Autonomy: </a:t>
+            </a:r>
+            <a:r>
+              <a:rPr sz="900">
+                <a:solidFill>
+                  <a:srgbClr val="0F172A"/>
+                </a:solidFill>
+              </a:rPr>
+              <a:t>Equipped with self-help grounding tools, box breathing guides, legal rights pamphlets, and transparent feedback channels.</a:t>
+            </a:r>
+          </a:p>
+        </p:txBody>
+      </p:sp>
+      <p:sp>
+        <p:nvSpPr>
+          <p:cNvPr id="17415" name="Rounded Rectangle 17414"/>
+          <p:cNvSpPr/>
+          <p:nvPr/>
+        </p:nvSpPr>
+        <p:spPr>
+          <a:xfrm>
+            <a:off x="5943600" y="2743200"/>
+            <a:ext cx="5760720" cy="3383280"/>
+          </a:xfrm>
+          <a:prstGeom prst="roundRect">
+            <a:avLst/>
+          </a:prstGeom>
+          <a:solidFill>
+            <a:srgbClr val="F5F8FA"/>
+          </a:solidFill>
+          <a:ln w="19050">
+            <a:solidFill>
+              <a:srgbClr val="108C5A"/>
+            </a:solidFill>
+          </a:ln>
+        </p:spPr>
+        <p:style>
+          <a:lnRef idx="1">
+            <a:schemeClr val="accent1"/>
+          </a:lnRef>
+          <a:fillRef idx="3">
+            <a:schemeClr val="accent1"/>
+          </a:fillRef>
+          <a:effectRef idx="2">
+            <a:schemeClr val="accent1"/>
+          </a:effectRef>
+          <a:fontRef idx="minor">
+            <a:schemeClr val="lt1"/>
+          </a:fontRef>
+        </p:style>
+        <p:txBody>
+          <a:bodyPr rtlCol="0" anchor="ctr" wrap="square" lIns="73152" rIns="73152" tIns="73152" bIns="73152"/>
+          <a:lstStyle/>
+          <a:p>
+            <a:pPr algn="ctr">
+              <a:spcAft>
+                <a:spcPts val="400"/>
+              </a:spcAft>
+              <a:defRPr b="1" sz="1200">
+                <a:solidFill>
+                  <a:srgbClr val="108C5A"/>
+                </a:solidFill>
+              </a:defRPr>
+            </a:pPr>
+            <a:r>
+              <a:t>Benefits of the Solution (Social, Legal, Administrative):</a:t>
+            </a:r>
+          </a:p>
+          <a:p>
+            <a:pPr>
+              <a:spcAft>
+                <a:spcPts val="250"/>
+              </a:spcAft>
+            </a:pPr>
+            <a:r>
+              <a:rPr b="1" sz="950">
+                <a:solidFill>
+                  <a:srgbClr val="0D5050"/>
+                </a:solidFill>
+              </a:rPr>
+              <a:t>• Early Crisis Detection &amp; Prevention: </a:t>
+            </a:r>
+            <a:r>
+              <a:rPr sz="900">
+                <a:solidFill>
+                  <a:srgbClr val="0F172A"/>
+                </a:solidFill>
+              </a:rPr>
+              <a:t>Intercepts acute distress 72 hours before crisis, enabling timely tele-counselling and suicide prevention.</a:t>
+            </a:r>
+          </a:p>
+          <a:p>
+            <a:pPr>
+              <a:spcAft>
+                <a:spcPts val="250"/>
+              </a:spcAft>
+            </a:pPr>
+            <a:r>
+              <a:rPr b="1" sz="950">
+                <a:solidFill>
+                  <a:srgbClr val="0D5050"/>
+                </a:solidFill>
+              </a:rPr>
+              <a:t>• Strengthened Justice System Trust: </a:t>
+            </a:r>
+            <a:r>
+              <a:rPr sz="900">
+                <a:solidFill>
+                  <a:srgbClr val="0F172A"/>
+                </a:solidFill>
+              </a:rPr>
+              <a:t>Proactive state care rebuilds victim faith, drastically reducing trial dropouts and witness hostility in court.</a:t>
+            </a:r>
+          </a:p>
+          <a:p>
+            <a:pPr>
+              <a:spcAft>
+                <a:spcPts val="250"/>
+              </a:spcAft>
+            </a:pPr>
+            <a:r>
+              <a:rPr b="1" sz="950">
+                <a:solidFill>
+                  <a:srgbClr val="0D5050"/>
+                </a:solidFill>
+              </a:rPr>
+              <a:t>• Multi-Agency Synergy: </a:t>
+            </a:r>
+            <a:r>
+              <a:rPr sz="900">
+                <a:solidFill>
+                  <a:srgbClr val="0F172A"/>
+                </a:solidFill>
+              </a:rPr>
+              <a:t>Unifies welfare departments, police liaisons, and tele-counsellors under a shared real-time incident workflow.</a:t>
+            </a:r>
+          </a:p>
+          <a:p>
+            <a:pPr>
+              <a:spcAft>
+                <a:spcPts val="250"/>
+              </a:spcAft>
+            </a:pPr>
+            <a:r>
+              <a:rPr b="1" sz="950">
+                <a:solidFill>
+                  <a:srgbClr val="0D5050"/>
+                </a:solidFill>
+              </a:rPr>
+              <a:t>• Evidence-Based Governance: </a:t>
+            </a:r>
+            <a:r>
+              <a:rPr sz="900">
+                <a:solidFill>
+                  <a:srgbClr val="0F172A"/>
+                </a:solidFill>
+              </a:rPr>
+              <a:t>State and National MoSJE heatmaps provide administrators and District Magistrates data-driven insights on atrocity hotspots.</a:t>
+            </a:r>
+          </a:p>
+          <a:p>
+            <a:pPr>
+              <a:spcAft>
+                <a:spcPts val="250"/>
+              </a:spcAft>
+            </a:pPr>
+            <a:r>
+              <a:rPr b="1" sz="950">
+                <a:solidFill>
+                  <a:srgbClr val="0D5050"/>
+                </a:solidFill>
+              </a:rPr>
+              <a:t>• Reduced Administrative Burden: </a:t>
+            </a:r>
+            <a:r>
+              <a:rPr sz="900">
+                <a:solidFill>
+                  <a:srgbClr val="0F172A"/>
+                </a:solidFill>
+              </a:rPr>
+              <a:t>Automated multichannel check-ins and AI triage cut manual welfare follow-up overhead by over 70%.</a:t>
+            </a:r>
+          </a:p>
+        </p:txBody>
+      </p:sp>
     </p:spTree>
     <p:extLst>
       <p:ext uri="{BB962C8B-B14F-4D97-AF65-F5344CB8AC3E}">
@@ -7652,130 +9521,6 @@
                 <a:cs typeface="Times New Roman" panose="02020603050405020304" pitchFamily="18" charset="0"/>
               </a:rPr>
               <a:t>RESEARCH  AND REFERENCES</a:t>
-            </a:r>
-          </a:p>
-        </p:txBody>
-      </p:sp>
-      <p:sp>
-        <p:nvSpPr>
-          <p:cNvPr id="17410" name="TextBox 8"/>
-          <p:cNvSpPr txBox="1">
-            <a:spLocks noChangeArrowheads="1"/>
-          </p:cNvSpPr>
-          <p:nvPr/>
-        </p:nvSpPr>
-        <p:spPr bwMode="auto">
-          <a:xfrm>
-            <a:off x="609600" y="2795263"/>
-            <a:ext cx="9385300" cy="523220"/>
-          </a:xfrm>
-          <a:prstGeom prst="rect">
-            <a:avLst/>
-          </a:prstGeom>
-          <a:noFill/>
-          <a:ln w="9525">
-            <a:noFill/>
-            <a:miter lim="800000"/>
-            <a:headEnd/>
-            <a:tailEnd/>
-          </a:ln>
-        </p:spPr>
-        <p:txBody>
-          <a:bodyPr wrap="square">
-            <a:spAutoFit/>
-          </a:bodyPr>
-          <a:lstStyle/>
-          <a:p>
-            <a:pPr marL="342900" marR="0" lvl="0" indent="-342900" algn="just" defTabSz="457200" rtl="0" eaLnBrk="1" fontAlgn="base" latinLnBrk="0" hangingPunct="1">
-              <a:lnSpc>
-                <a:spcPct val="100000"/>
-              </a:lnSpc>
-              <a:spcBef>
-                <a:spcPct val="0"/>
-              </a:spcBef>
-              <a:spcAft>
-                <a:spcPct val="0"/>
-              </a:spcAft>
-              <a:buClrTx/>
-              <a:buSzTx/>
-              <a:buFont typeface="Arial" panose="020B0604020202020204" pitchFamily="34" charset="0"/>
-              <a:buChar char="•"/>
-              <a:tabLst/>
-              <a:defRPr/>
-            </a:pPr>
-            <a:endParaRPr kumimoji="0" lang="en-US" sz="2800" b="0" i="0" u="none" strike="noStrike" kern="1200" cap="none" spc="0" normalizeH="0" baseline="0" noProof="0" dirty="0">
-              <a:ln>
-                <a:noFill/>
-              </a:ln>
-              <a:solidFill>
-                <a:prstClr val="black"/>
-              </a:solidFill>
-              <a:effectLst/>
-              <a:uLnTx/>
-              <a:uFillTx/>
-              <a:latin typeface="Arial" pitchFamily="34" charset="0"/>
-              <a:ea typeface="ＭＳ Ｐゴシック" pitchFamily="1" charset="-128"/>
-              <a:cs typeface="Arial" pitchFamily="34" charset="0"/>
-            </a:endParaRPr>
-          </a:p>
-          <a:p>
-            <a:pPr>
-              <a:spcAft>
-                <a:spcPts val="600"/>
-              </a:spcAft>
-              <a:defRPr sz="1200">
-                <a:solidFill>
-                  <a:srgbClr val="1E293B"/>
-                </a:solidFill>
-              </a:defRPr>
-            </a:pPr>
-            <a:r>
-              <a:t>• Legal &amp; Statutory Frameworks: 1) SC/ST (Prevention of Atrocities) Act, 1989 &amp; Rules 1995 (Victim Relief &amp; Protection). 2) MoSJE National Helpline Against Atrocities (NHAA 14566). 3) Digital Personal Data Protection (DPDP) Act 2023.</a:t>
-            </a:r>
-          </a:p>
-          <a:p>
-            <a:pPr>
-              <a:spcAft>
-                <a:spcPts val="600"/>
-              </a:spcAft>
-              <a:defRPr sz="1200">
-                <a:solidFill>
-                  <a:srgbClr val="1E293B"/>
-                </a:solidFill>
-              </a:defRPr>
-            </a:pPr>
-            <a:r>
-              <a:t>• Clinical Trauma &amp; Vocal Stress Research: 1) DSM-5 PTSD &amp; Acute Distress Clinical Metrics. 2) Scherer et al. (2013) Acoustic Markers of Speech Under Psychological Stress (Pitch tremor, jitter %, pause duration).</a:t>
-            </a:r>
-          </a:p>
-          <a:p>
-            <a:pPr>
-              <a:spcAft>
-                <a:spcPts val="600"/>
-              </a:spcAft>
-              <a:defRPr sz="1200">
-                <a:solidFill>
-                  <a:srgbClr val="1E293B"/>
-                </a:solidFill>
-              </a:defRPr>
-            </a:pPr>
-            <a:r>
-              <a:t>• Explainable AI &amp; Time-Series Modeling: 1) Lundberg &amp; Lee (2017) Unified Approach to Interpreting Model Predictions (SHAP). 2) Longitudinal trend velocity (dDDS/dt) forecasting models.</a:t>
-            </a:r>
-          </a:p>
-          <a:p>
-            <a:pPr>
-              <a:spcAft>
-                <a:spcPts val="600"/>
-              </a:spcAft>
-              <a:defRPr sz="1200">
-                <a:solidFill>
-                  <a:srgbClr val="1E293B"/>
-                </a:solidFill>
-              </a:defRPr>
-            </a:pPr>
-            <a:r>
-              <a:t>• Official Project Repository &amp; Live Prototype: Full working source code, API backend &amp; React frontend available at https://github.com/balajikrishnan031/SIH-KEFI</a:t>
             </a:r>
           </a:p>
         </p:txBody>
@@ -7976,11 +9721,16 @@
           <a:bodyPr rtlCol="0" anchor="ctr"/>
           <a:lstStyle/>
           <a:p>
-            <a:pPr algn="ctr"/>
+            <a:pPr>
+              <a:defRPr b="1" sz="1400">
+                <a:solidFill>
+                  <a:srgbClr val="0D5050"/>
+                </a:solidFill>
+              </a:defRPr>
+            </a:pPr>
             <a:r>
               <a:t>DEKO</a:t>
             </a:r>
-            <a:endParaRPr lang="en-IN" dirty="0"/>
           </a:p>
         </p:txBody>
       </p:sp>
@@ -8014,6 +9764,1049 @@
           </a:prstGeom>
         </p:spPr>
       </p:pic>
+      <p:sp>
+        <p:nvSpPr>
+          <p:cNvPr id="17410" name="Rounded Rectangle 17409"/>
+          <p:cNvSpPr/>
+          <p:nvPr/>
+        </p:nvSpPr>
+        <p:spPr>
+          <a:xfrm>
+            <a:off x="365760" y="1188720"/>
+            <a:ext cx="11338560" cy="2011680"/>
+          </a:xfrm>
+          <a:prstGeom prst="roundRect">
+            <a:avLst/>
+          </a:prstGeom>
+          <a:solidFill>
+            <a:srgbClr val="F5F8FA"/>
+          </a:solidFill>
+          <a:ln w="19050">
+            <a:solidFill>
+              <a:srgbClr val="1A7A7A"/>
+            </a:solidFill>
+          </a:ln>
+        </p:spPr>
+        <p:style>
+          <a:lnRef idx="1">
+            <a:schemeClr val="accent1"/>
+          </a:lnRef>
+          <a:fillRef idx="3">
+            <a:schemeClr val="accent1"/>
+          </a:fillRef>
+          <a:effectRef idx="2">
+            <a:schemeClr val="accent1"/>
+          </a:effectRef>
+          <a:fontRef idx="minor">
+            <a:schemeClr val="lt1"/>
+          </a:fontRef>
+        </p:style>
+        <p:txBody>
+          <a:bodyPr rtlCol="0" anchor="ctr" wrap="square" lIns="73152" rIns="73152" tIns="73152" bIns="73152"/>
+          <a:lstStyle/>
+          <a:p>
+            <a:pPr algn="ctr">
+              <a:spcAft>
+                <a:spcPts val="400"/>
+              </a:spcAft>
+              <a:defRPr b="1" sz="1200">
+                <a:solidFill>
+                  <a:srgbClr val="0D5050"/>
+                </a:solidFill>
+              </a:defRPr>
+            </a:pPr>
+            <a:r>
+              <a:t>Reference Links &amp; Research Work:</a:t>
+            </a:r>
+          </a:p>
+          <a:p>
+            <a:pPr>
+              <a:spcAft>
+                <a:spcPts val="150"/>
+              </a:spcAft>
+            </a:pPr>
+            <a:r>
+              <a:rPr b="1" sz="950">
+                <a:solidFill>
+                  <a:srgbClr val="0D5050"/>
+                </a:solidFill>
+              </a:rPr>
+              <a:t>• Statutory Act: </a:t>
+            </a:r>
+            <a:r>
+              <a:rPr sz="900">
+                <a:solidFill>
+                  <a:srgbClr val="0F172A"/>
+                </a:solidFill>
+              </a:rPr>
+              <a:t>Scheduled Castes and the Scheduled Tribes (Prevention of Atrocities) Act, 1989 &amp; PoA Rules 1995: https://socialjustice.gov.in</a:t>
+            </a:r>
+          </a:p>
+          <a:p>
+            <a:pPr>
+              <a:spcAft>
+                <a:spcPts val="150"/>
+              </a:spcAft>
+            </a:pPr>
+            <a:r>
+              <a:rPr b="1" sz="950">
+                <a:solidFill>
+                  <a:srgbClr val="0D5050"/>
+                </a:solidFill>
+              </a:rPr>
+              <a:t>• National Helpline: </a:t>
+            </a:r>
+            <a:r>
+              <a:rPr sz="900">
+                <a:solidFill>
+                  <a:srgbClr val="0F172A"/>
+                </a:solidFill>
+              </a:rPr>
+              <a:t>MoSJE National Helpline Against Atrocities (NHAA 14566) Integration: https://socialjustice.gov.in/schemes/nhaa</a:t>
+            </a:r>
+          </a:p>
+          <a:p>
+            <a:pPr>
+              <a:spcAft>
+                <a:spcPts val="150"/>
+              </a:spcAft>
+            </a:pPr>
+            <a:r>
+              <a:rPr b="1" sz="950">
+                <a:solidFill>
+                  <a:srgbClr val="0D5050"/>
+                </a:solidFill>
+              </a:rPr>
+              <a:t>• Data Privacy Law: </a:t>
+            </a:r>
+            <a:r>
+              <a:rPr sz="900">
+                <a:solidFill>
+                  <a:srgbClr val="0F172A"/>
+                </a:solidFill>
+              </a:rPr>
+              <a:t>Digital Personal Data Protection (DPDP) Act, 2023 — Government of India: https://www.meity.gov.in/dpdp-act</a:t>
+            </a:r>
+          </a:p>
+          <a:p>
+            <a:pPr>
+              <a:spcAft>
+                <a:spcPts val="150"/>
+              </a:spcAft>
+            </a:pPr>
+            <a:r>
+              <a:rPr b="1" sz="950">
+                <a:solidFill>
+                  <a:srgbClr val="0D5050"/>
+                </a:solidFill>
+              </a:rPr>
+              <a:t>• Clinical Research: </a:t>
+            </a:r>
+            <a:r>
+              <a:rPr sz="900">
+                <a:solidFill>
+                  <a:srgbClr val="0F172A"/>
+                </a:solidFill>
+              </a:rPr>
+              <a:t>Scherer, K. R., et al. (2013). Acoustic Markers of Speech Under Psychological Stress. Computer Speech &amp; Language.</a:t>
+            </a:r>
+          </a:p>
+          <a:p>
+            <a:pPr>
+              <a:spcAft>
+                <a:spcPts val="150"/>
+              </a:spcAft>
+            </a:pPr>
+            <a:r>
+              <a:rPr b="1" sz="950">
+                <a:solidFill>
+                  <a:srgbClr val="0D5050"/>
+                </a:solidFill>
+              </a:rPr>
+              <a:t>• Explainable AI: </a:t>
+            </a:r>
+            <a:r>
+              <a:rPr sz="900">
+                <a:solidFill>
+                  <a:srgbClr val="0F172A"/>
+                </a:solidFill>
+              </a:rPr>
+              <a:t>Lundberg, S. M., &amp; Lee, S.-I. (2017). A Unified Approach to Interpreting Model Predictions (SHAP). NeurIPS.</a:t>
+            </a:r>
+          </a:p>
+          <a:p>
+            <a:pPr>
+              <a:spcAft>
+                <a:spcPts val="150"/>
+              </a:spcAft>
+            </a:pPr>
+            <a:r>
+              <a:rPr b="1" sz="950">
+                <a:solidFill>
+                  <a:srgbClr val="0D5050"/>
+                </a:solidFill>
+              </a:rPr>
+              <a:t>• Project Repository: </a:t>
+            </a:r>
+            <a:r>
+              <a:rPr sz="900">
+                <a:solidFill>
+                  <a:srgbClr val="0F172A"/>
+                </a:solidFill>
+              </a:rPr>
+              <a:t>KEFI AI Full Source Code &amp; Web Application: https://github.com/balajikrishnan031/SIH-KEFI</a:t>
+            </a:r>
+          </a:p>
+        </p:txBody>
+      </p:sp>
+      <p:graphicFrame>
+        <p:nvGraphicFramePr>
+          <p:cNvPr id="17411" name="Table 17410"/>
+          <p:cNvGraphicFramePr>
+            <a:graphicFrameLocks noGrp="1"/>
+          </p:cNvGraphicFramePr>
+          <p:nvPr/>
+        </p:nvGraphicFramePr>
+        <p:xfrm>
+          <a:off x="365760" y="3383280"/>
+          <a:ext cx="11338560" cy="2743200"/>
+        </p:xfrm>
+        <a:graphic>
+          <a:graphicData uri="http://schemas.openxmlformats.org/drawingml/2006/table">
+            <a:tbl>
+              <a:tblPr firstRow="1" bandRow="1">
+                <a:tableStyleId>{5C22544A-7EE6-4342-B048-85BDC9FD1C3A}</a:tableStyleId>
+              </a:tblPr>
+              <a:tblGrid>
+                <a:gridCol w="2377440"/>
+                <a:gridCol w="1645920"/>
+                <a:gridCol w="1645920"/>
+                <a:gridCol w="1645920"/>
+                <a:gridCol w="4023360"/>
+              </a:tblGrid>
+              <a:tr h="391885">
+                <a:tc>
+                  <a:txBody>
+                    <a:bodyPr wrap="square" lIns="73152" rIns="73152" tIns="73152" bIns="73152"/>
+                    <a:lstStyle/>
+                    <a:p>
+                      <a:pPr>
+                        <a:defRPr b="1" sz="1000">
+                          <a:solidFill>
+                            <a:srgbClr val="FFFFFF"/>
+                          </a:solidFill>
+                        </a:defRPr>
+                      </a:pPr>
+                      <a:r>
+                        <a:t>TEAM MEMBER</a:t>
+                      </a:r>
+                    </a:p>
+                  </a:txBody>
+                  <a:tcPr anchor="ctr">
+                    <a:solidFill>
+                      <a:srgbClr val="0D5050"/>
+                    </a:solidFill>
+                  </a:tcPr>
+                </a:tc>
+                <a:tc>
+                  <a:txBody>
+                    <a:bodyPr wrap="square" lIns="73152" rIns="73152" tIns="73152" bIns="73152"/>
+                    <a:lstStyle/>
+                    <a:p>
+                      <a:pPr>
+                        <a:defRPr b="1" sz="1000">
+                          <a:solidFill>
+                            <a:srgbClr val="FFFFFF"/>
+                          </a:solidFill>
+                        </a:defRPr>
+                      </a:pPr>
+                      <a:r>
+                        <a:t>STREAM</a:t>
+                      </a:r>
+                    </a:p>
+                  </a:txBody>
+                  <a:tcPr anchor="ctr">
+                    <a:solidFill>
+                      <a:srgbClr val="0D5050"/>
+                    </a:solidFill>
+                  </a:tcPr>
+                </a:tc>
+                <a:tc>
+                  <a:txBody>
+                    <a:bodyPr wrap="square" lIns="73152" rIns="73152" tIns="73152" bIns="73152"/>
+                    <a:lstStyle/>
+                    <a:p>
+                      <a:pPr>
+                        <a:defRPr b="1" sz="1000">
+                          <a:solidFill>
+                            <a:srgbClr val="FFFFFF"/>
+                          </a:solidFill>
+                        </a:defRPr>
+                      </a:pPr>
+                      <a:r>
+                        <a:t>BRANCH</a:t>
+                      </a:r>
+                    </a:p>
+                  </a:txBody>
+                  <a:tcPr anchor="ctr">
+                    <a:solidFill>
+                      <a:srgbClr val="0D5050"/>
+                    </a:solidFill>
+                  </a:tcPr>
+                </a:tc>
+                <a:tc>
+                  <a:txBody>
+                    <a:bodyPr wrap="square" lIns="73152" rIns="73152" tIns="73152" bIns="73152"/>
+                    <a:lstStyle/>
+                    <a:p>
+                      <a:pPr>
+                        <a:defRPr b="1" sz="1000">
+                          <a:solidFill>
+                            <a:srgbClr val="FFFFFF"/>
+                          </a:solidFill>
+                        </a:defRPr>
+                      </a:pPr>
+                      <a:r>
+                        <a:t>YEAR</a:t>
+                      </a:r>
+                    </a:p>
+                  </a:txBody>
+                  <a:tcPr anchor="ctr">
+                    <a:solidFill>
+                      <a:srgbClr val="0D5050"/>
+                    </a:solidFill>
+                  </a:tcPr>
+                </a:tc>
+                <a:tc>
+                  <a:txBody>
+                    <a:bodyPr wrap="square" lIns="73152" rIns="73152" tIns="73152" bIns="73152"/>
+                    <a:lstStyle/>
+                    <a:p>
+                      <a:pPr>
+                        <a:defRPr b="1" sz="1000">
+                          <a:solidFill>
+                            <a:srgbClr val="FFFFFF"/>
+                          </a:solidFill>
+                        </a:defRPr>
+                      </a:pPr>
+                      <a:r>
+                        <a:t>ROLE / CONTACT</a:t>
+                      </a:r>
+                    </a:p>
+                  </a:txBody>
+                  <a:tcPr anchor="ctr">
+                    <a:solidFill>
+                      <a:srgbClr val="0D5050"/>
+                    </a:solidFill>
+                  </a:tcPr>
+                </a:tc>
+              </a:tr>
+              <a:tr h="391885">
+                <a:tc>
+                  <a:txBody>
+                    <a:bodyPr wrap="square" lIns="73152" rIns="73152" tIns="73152" bIns="73152"/>
+                    <a:lstStyle/>
+                    <a:p>
+                      <a:pPr>
+                        <a:defRPr sz="900" b="1">
+                          <a:solidFill>
+                            <a:srgbClr val="0F172A"/>
+                          </a:solidFill>
+                        </a:defRPr>
+                      </a:pPr>
+                      <a:r>
+                        <a:t>BALAJI P</a:t>
+                      </a:r>
+                    </a:p>
+                  </a:txBody>
+                  <a:tcPr anchor="ctr">
+                    <a:solidFill>
+                      <a:srgbClr val="FFFFFF"/>
+                    </a:solidFill>
+                  </a:tcPr>
+                </a:tc>
+                <a:tc>
+                  <a:txBody>
+                    <a:bodyPr wrap="square" lIns="73152" rIns="73152" tIns="73152" bIns="73152"/>
+                    <a:lstStyle/>
+                    <a:p>
+                      <a:pPr>
+                        <a:defRPr sz="900">
+                          <a:solidFill>
+                            <a:srgbClr val="0F172A"/>
+                          </a:solidFill>
+                        </a:defRPr>
+                      </a:pPr>
+                      <a:r>
+                        <a:t>B.E</a:t>
+                      </a:r>
+                    </a:p>
+                  </a:txBody>
+                  <a:tcPr anchor="ctr">
+                    <a:solidFill>
+                      <a:srgbClr val="FFFFFF"/>
+                    </a:solidFill>
+                  </a:tcPr>
+                </a:tc>
+                <a:tc>
+                  <a:txBody>
+                    <a:bodyPr wrap="square" lIns="73152" rIns="73152" tIns="73152" bIns="73152"/>
+                    <a:lstStyle/>
+                    <a:p>
+                      <a:pPr>
+                        <a:defRPr sz="900">
+                          <a:solidFill>
+                            <a:srgbClr val="0F172A"/>
+                          </a:solidFill>
+                        </a:defRPr>
+                      </a:pPr>
+                      <a:r>
+                        <a:t>CSE</a:t>
+                      </a:r>
+                    </a:p>
+                  </a:txBody>
+                  <a:tcPr anchor="ctr">
+                    <a:solidFill>
+                      <a:srgbClr val="FFFFFF"/>
+                    </a:solidFill>
+                  </a:tcPr>
+                </a:tc>
+                <a:tc>
+                  <a:txBody>
+                    <a:bodyPr wrap="square" lIns="73152" rIns="73152" tIns="73152" bIns="73152"/>
+                    <a:lstStyle/>
+                    <a:p>
+                      <a:pPr>
+                        <a:defRPr sz="900">
+                          <a:solidFill>
+                            <a:srgbClr val="0F172A"/>
+                          </a:solidFill>
+                        </a:defRPr>
+                      </a:pPr>
+                      <a:r>
+                        <a:t>IV</a:t>
+                      </a:r>
+                    </a:p>
+                  </a:txBody>
+                  <a:tcPr anchor="ctr">
+                    <a:solidFill>
+                      <a:srgbClr val="FFFFFF"/>
+                    </a:solidFill>
+                  </a:tcPr>
+                </a:tc>
+                <a:tc>
+                  <a:txBody>
+                    <a:bodyPr wrap="square" lIns="73152" rIns="73152" tIns="73152" bIns="73152"/>
+                    <a:lstStyle/>
+                    <a:p>
+                      <a:pPr>
+                        <a:defRPr sz="900">
+                          <a:solidFill>
+                            <a:srgbClr val="0F172A"/>
+                          </a:solidFill>
+                        </a:defRPr>
+                      </a:pPr>
+                      <a:r>
+                        <a:t>LEADER (balajikrishnan031@gmail.com | 9342636595)</a:t>
+                      </a:r>
+                    </a:p>
+                  </a:txBody>
+                  <a:tcPr anchor="ctr">
+                    <a:solidFill>
+                      <a:srgbClr val="FFFFFF"/>
+                    </a:solidFill>
+                  </a:tcPr>
+                </a:tc>
+              </a:tr>
+              <a:tr h="391885">
+                <a:tc>
+                  <a:txBody>
+                    <a:bodyPr wrap="square" lIns="73152" rIns="73152" tIns="73152" bIns="73152"/>
+                    <a:lstStyle/>
+                    <a:p>
+                      <a:pPr>
+                        <a:defRPr sz="900" b="1">
+                          <a:solidFill>
+                            <a:srgbClr val="0F172A"/>
+                          </a:solidFill>
+                        </a:defRPr>
+                      </a:pPr>
+                      <a:r>
+                        <a:t>NAVANEETHAM V</a:t>
+                      </a:r>
+                    </a:p>
+                  </a:txBody>
+                  <a:tcPr anchor="ctr">
+                    <a:solidFill>
+                      <a:srgbClr val="F5F8FA"/>
+                    </a:solidFill>
+                  </a:tcPr>
+                </a:tc>
+                <a:tc>
+                  <a:txBody>
+                    <a:bodyPr wrap="square" lIns="73152" rIns="73152" tIns="73152" bIns="73152"/>
+                    <a:lstStyle/>
+                    <a:p>
+                      <a:pPr>
+                        <a:defRPr sz="900">
+                          <a:solidFill>
+                            <a:srgbClr val="0F172A"/>
+                          </a:solidFill>
+                        </a:defRPr>
+                      </a:pPr>
+                      <a:r>
+                        <a:t>B.E</a:t>
+                      </a:r>
+                    </a:p>
+                  </a:txBody>
+                  <a:tcPr anchor="ctr">
+                    <a:solidFill>
+                      <a:srgbClr val="F5F8FA"/>
+                    </a:solidFill>
+                  </a:tcPr>
+                </a:tc>
+                <a:tc>
+                  <a:txBody>
+                    <a:bodyPr wrap="square" lIns="73152" rIns="73152" tIns="73152" bIns="73152"/>
+                    <a:lstStyle/>
+                    <a:p>
+                      <a:pPr>
+                        <a:defRPr sz="900">
+                          <a:solidFill>
+                            <a:srgbClr val="0F172A"/>
+                          </a:solidFill>
+                        </a:defRPr>
+                      </a:pPr>
+                      <a:r>
+                        <a:t>CSE</a:t>
+                      </a:r>
+                    </a:p>
+                  </a:txBody>
+                  <a:tcPr anchor="ctr">
+                    <a:solidFill>
+                      <a:srgbClr val="F5F8FA"/>
+                    </a:solidFill>
+                  </a:tcPr>
+                </a:tc>
+                <a:tc>
+                  <a:txBody>
+                    <a:bodyPr wrap="square" lIns="73152" rIns="73152" tIns="73152" bIns="73152"/>
+                    <a:lstStyle/>
+                    <a:p>
+                      <a:pPr>
+                        <a:defRPr sz="900">
+                          <a:solidFill>
+                            <a:srgbClr val="0F172A"/>
+                          </a:solidFill>
+                        </a:defRPr>
+                      </a:pPr>
+                      <a:r>
+                        <a:t>IV</a:t>
+                      </a:r>
+                    </a:p>
+                  </a:txBody>
+                  <a:tcPr anchor="ctr">
+                    <a:solidFill>
+                      <a:srgbClr val="F5F8FA"/>
+                    </a:solidFill>
+                  </a:tcPr>
+                </a:tc>
+                <a:tc>
+                  <a:txBody>
+                    <a:bodyPr wrap="square" lIns="73152" rIns="73152" tIns="73152" bIns="73152"/>
+                    <a:lstStyle/>
+                    <a:p>
+                      <a:pPr>
+                        <a:defRPr sz="900">
+                          <a:solidFill>
+                            <a:srgbClr val="0F172A"/>
+                          </a:solidFill>
+                        </a:defRPr>
+                      </a:pPr>
+                      <a:r>
+                        <a:t>TEAM_MEMBER (er.navaneetham@gmail.com | 9487461627)</a:t>
+                      </a:r>
+                    </a:p>
+                  </a:txBody>
+                  <a:tcPr anchor="ctr">
+                    <a:solidFill>
+                      <a:srgbClr val="F5F8FA"/>
+                    </a:solidFill>
+                  </a:tcPr>
+                </a:tc>
+              </a:tr>
+              <a:tr h="391885">
+                <a:tc>
+                  <a:txBody>
+                    <a:bodyPr wrap="square" lIns="73152" rIns="73152" tIns="73152" bIns="73152"/>
+                    <a:lstStyle/>
+                    <a:p>
+                      <a:pPr>
+                        <a:defRPr sz="900" b="1">
+                          <a:solidFill>
+                            <a:srgbClr val="0F172A"/>
+                          </a:solidFill>
+                        </a:defRPr>
+                      </a:pPr>
+                      <a:r>
+                        <a:t>MALINI V</a:t>
+                      </a:r>
+                    </a:p>
+                  </a:txBody>
+                  <a:tcPr anchor="ctr">
+                    <a:solidFill>
+                      <a:srgbClr val="FFFFFF"/>
+                    </a:solidFill>
+                  </a:tcPr>
+                </a:tc>
+                <a:tc>
+                  <a:txBody>
+                    <a:bodyPr wrap="square" lIns="73152" rIns="73152" tIns="73152" bIns="73152"/>
+                    <a:lstStyle/>
+                    <a:p>
+                      <a:pPr>
+                        <a:defRPr sz="900">
+                          <a:solidFill>
+                            <a:srgbClr val="0F172A"/>
+                          </a:solidFill>
+                        </a:defRPr>
+                      </a:pPr>
+                      <a:r>
+                        <a:t>B.E</a:t>
+                      </a:r>
+                    </a:p>
+                  </a:txBody>
+                  <a:tcPr anchor="ctr">
+                    <a:solidFill>
+                      <a:srgbClr val="FFFFFF"/>
+                    </a:solidFill>
+                  </a:tcPr>
+                </a:tc>
+                <a:tc>
+                  <a:txBody>
+                    <a:bodyPr wrap="square" lIns="73152" rIns="73152" tIns="73152" bIns="73152"/>
+                    <a:lstStyle/>
+                    <a:p>
+                      <a:pPr>
+                        <a:defRPr sz="900">
+                          <a:solidFill>
+                            <a:srgbClr val="0F172A"/>
+                          </a:solidFill>
+                        </a:defRPr>
+                      </a:pPr>
+                      <a:r>
+                        <a:t>CSE</a:t>
+                      </a:r>
+                    </a:p>
+                  </a:txBody>
+                  <a:tcPr anchor="ctr">
+                    <a:solidFill>
+                      <a:srgbClr val="FFFFFF"/>
+                    </a:solidFill>
+                  </a:tcPr>
+                </a:tc>
+                <a:tc>
+                  <a:txBody>
+                    <a:bodyPr wrap="square" lIns="73152" rIns="73152" tIns="73152" bIns="73152"/>
+                    <a:lstStyle/>
+                    <a:p>
+                      <a:pPr>
+                        <a:defRPr sz="900">
+                          <a:solidFill>
+                            <a:srgbClr val="0F172A"/>
+                          </a:solidFill>
+                        </a:defRPr>
+                      </a:pPr>
+                      <a:r>
+                        <a:t>IV</a:t>
+                      </a:r>
+                    </a:p>
+                  </a:txBody>
+                  <a:tcPr anchor="ctr">
+                    <a:solidFill>
+                      <a:srgbClr val="FFFFFF"/>
+                    </a:solidFill>
+                  </a:tcPr>
+                </a:tc>
+                <a:tc>
+                  <a:txBody>
+                    <a:bodyPr wrap="square" lIns="73152" rIns="73152" tIns="73152" bIns="73152"/>
+                    <a:lstStyle/>
+                    <a:p>
+                      <a:pPr>
+                        <a:defRPr sz="900">
+                          <a:solidFill>
+                            <a:srgbClr val="0F172A"/>
+                          </a:solidFill>
+                        </a:defRPr>
+                      </a:pPr>
+                      <a:r>
+                        <a:t>TEAM_MEMBER (malini28102005v@gmail.com | 8807984385)</a:t>
+                      </a:r>
+                    </a:p>
+                  </a:txBody>
+                  <a:tcPr anchor="ctr">
+                    <a:solidFill>
+                      <a:srgbClr val="FFFFFF"/>
+                    </a:solidFill>
+                  </a:tcPr>
+                </a:tc>
+              </a:tr>
+              <a:tr h="391885">
+                <a:tc>
+                  <a:txBody>
+                    <a:bodyPr wrap="square" lIns="73152" rIns="73152" tIns="73152" bIns="73152"/>
+                    <a:lstStyle/>
+                    <a:p>
+                      <a:pPr>
+                        <a:defRPr sz="900" b="1">
+                          <a:solidFill>
+                            <a:srgbClr val="0F172A"/>
+                          </a:solidFill>
+                        </a:defRPr>
+                      </a:pPr>
+                      <a:r>
+                        <a:t>DHAVAN R G</a:t>
+                      </a:r>
+                    </a:p>
+                  </a:txBody>
+                  <a:tcPr anchor="ctr">
+                    <a:solidFill>
+                      <a:srgbClr val="F5F8FA"/>
+                    </a:solidFill>
+                  </a:tcPr>
+                </a:tc>
+                <a:tc>
+                  <a:txBody>
+                    <a:bodyPr wrap="square" lIns="73152" rIns="73152" tIns="73152" bIns="73152"/>
+                    <a:lstStyle/>
+                    <a:p>
+                      <a:pPr>
+                        <a:defRPr sz="900">
+                          <a:solidFill>
+                            <a:srgbClr val="0F172A"/>
+                          </a:solidFill>
+                        </a:defRPr>
+                      </a:pPr>
+                      <a:r>
+                        <a:t>B.E</a:t>
+                      </a:r>
+                    </a:p>
+                  </a:txBody>
+                  <a:tcPr anchor="ctr">
+                    <a:solidFill>
+                      <a:srgbClr val="F5F8FA"/>
+                    </a:solidFill>
+                  </a:tcPr>
+                </a:tc>
+                <a:tc>
+                  <a:txBody>
+                    <a:bodyPr wrap="square" lIns="73152" rIns="73152" tIns="73152" bIns="73152"/>
+                    <a:lstStyle/>
+                    <a:p>
+                      <a:pPr>
+                        <a:defRPr sz="900">
+                          <a:solidFill>
+                            <a:srgbClr val="0F172A"/>
+                          </a:solidFill>
+                        </a:defRPr>
+                      </a:pPr>
+                      <a:r>
+                        <a:t>CSE</a:t>
+                      </a:r>
+                    </a:p>
+                  </a:txBody>
+                  <a:tcPr anchor="ctr">
+                    <a:solidFill>
+                      <a:srgbClr val="F5F8FA"/>
+                    </a:solidFill>
+                  </a:tcPr>
+                </a:tc>
+                <a:tc>
+                  <a:txBody>
+                    <a:bodyPr wrap="square" lIns="73152" rIns="73152" tIns="73152" bIns="73152"/>
+                    <a:lstStyle/>
+                    <a:p>
+                      <a:pPr>
+                        <a:defRPr sz="900">
+                          <a:solidFill>
+                            <a:srgbClr val="0F172A"/>
+                          </a:solidFill>
+                        </a:defRPr>
+                      </a:pPr>
+                      <a:r>
+                        <a:t>IV</a:t>
+                      </a:r>
+                    </a:p>
+                  </a:txBody>
+                  <a:tcPr anchor="ctr">
+                    <a:solidFill>
+                      <a:srgbClr val="F5F8FA"/>
+                    </a:solidFill>
+                  </a:tcPr>
+                </a:tc>
+                <a:tc>
+                  <a:txBody>
+                    <a:bodyPr wrap="square" lIns="73152" rIns="73152" tIns="73152" bIns="73152"/>
+                    <a:lstStyle/>
+                    <a:p>
+                      <a:pPr>
+                        <a:defRPr sz="900">
+                          <a:solidFill>
+                            <a:srgbClr val="0F172A"/>
+                          </a:solidFill>
+                        </a:defRPr>
+                      </a:pPr>
+                      <a:r>
+                        <a:t>TEAM_MEMBER (rgdhavan50@gmail.com | 9342529181)</a:t>
+                      </a:r>
+                    </a:p>
+                  </a:txBody>
+                  <a:tcPr anchor="ctr">
+                    <a:solidFill>
+                      <a:srgbClr val="F5F8FA"/>
+                    </a:solidFill>
+                  </a:tcPr>
+                </a:tc>
+              </a:tr>
+              <a:tr h="391885">
+                <a:tc>
+                  <a:txBody>
+                    <a:bodyPr wrap="square" lIns="73152" rIns="73152" tIns="73152" bIns="73152"/>
+                    <a:lstStyle/>
+                    <a:p>
+                      <a:pPr>
+                        <a:defRPr sz="900" b="1">
+                          <a:solidFill>
+                            <a:srgbClr val="0F172A"/>
+                          </a:solidFill>
+                        </a:defRPr>
+                      </a:pPr>
+                      <a:r>
+                        <a:t>DEEBIKA S</a:t>
+                      </a:r>
+                    </a:p>
+                  </a:txBody>
+                  <a:tcPr anchor="ctr">
+                    <a:solidFill>
+                      <a:srgbClr val="FFFFFF"/>
+                    </a:solidFill>
+                  </a:tcPr>
+                </a:tc>
+                <a:tc>
+                  <a:txBody>
+                    <a:bodyPr wrap="square" lIns="73152" rIns="73152" tIns="73152" bIns="73152"/>
+                    <a:lstStyle/>
+                    <a:p>
+                      <a:pPr>
+                        <a:defRPr sz="900">
+                          <a:solidFill>
+                            <a:srgbClr val="0F172A"/>
+                          </a:solidFill>
+                        </a:defRPr>
+                      </a:pPr>
+                      <a:r>
+                        <a:t>B.E</a:t>
+                      </a:r>
+                    </a:p>
+                  </a:txBody>
+                  <a:tcPr anchor="ctr">
+                    <a:solidFill>
+                      <a:srgbClr val="FFFFFF"/>
+                    </a:solidFill>
+                  </a:tcPr>
+                </a:tc>
+                <a:tc>
+                  <a:txBody>
+                    <a:bodyPr wrap="square" lIns="73152" rIns="73152" tIns="73152" bIns="73152"/>
+                    <a:lstStyle/>
+                    <a:p>
+                      <a:pPr>
+                        <a:defRPr sz="900">
+                          <a:solidFill>
+                            <a:srgbClr val="0F172A"/>
+                          </a:solidFill>
+                        </a:defRPr>
+                      </a:pPr>
+                      <a:r>
+                        <a:t>CSE</a:t>
+                      </a:r>
+                    </a:p>
+                  </a:txBody>
+                  <a:tcPr anchor="ctr">
+                    <a:solidFill>
+                      <a:srgbClr val="FFFFFF"/>
+                    </a:solidFill>
+                  </a:tcPr>
+                </a:tc>
+                <a:tc>
+                  <a:txBody>
+                    <a:bodyPr wrap="square" lIns="73152" rIns="73152" tIns="73152" bIns="73152"/>
+                    <a:lstStyle/>
+                    <a:p>
+                      <a:pPr>
+                        <a:defRPr sz="900">
+                          <a:solidFill>
+                            <a:srgbClr val="0F172A"/>
+                          </a:solidFill>
+                        </a:defRPr>
+                      </a:pPr>
+                      <a:r>
+                        <a:t>IV</a:t>
+                      </a:r>
+                    </a:p>
+                  </a:txBody>
+                  <a:tcPr anchor="ctr">
+                    <a:solidFill>
+                      <a:srgbClr val="FFFFFF"/>
+                    </a:solidFill>
+                  </a:tcPr>
+                </a:tc>
+                <a:tc>
+                  <a:txBody>
+                    <a:bodyPr wrap="square" lIns="73152" rIns="73152" tIns="73152" bIns="73152"/>
+                    <a:lstStyle/>
+                    <a:p>
+                      <a:pPr>
+                        <a:defRPr sz="900">
+                          <a:solidFill>
+                            <a:srgbClr val="0F172A"/>
+                          </a:solidFill>
+                        </a:defRPr>
+                      </a:pPr>
+                      <a:r>
+                        <a:t>TEAM_MEMBER (deebikasivaprakasam@gmail.com | 6380433293)</a:t>
+                      </a:r>
+                    </a:p>
+                  </a:txBody>
+                  <a:tcPr anchor="ctr">
+                    <a:solidFill>
+                      <a:srgbClr val="FFFFFF"/>
+                    </a:solidFill>
+                  </a:tcPr>
+                </a:tc>
+              </a:tr>
+              <a:tr h="391890">
+                <a:tc>
+                  <a:txBody>
+                    <a:bodyPr wrap="square" lIns="73152" rIns="73152" tIns="73152" bIns="73152"/>
+                    <a:lstStyle/>
+                    <a:p>
+                      <a:pPr>
+                        <a:defRPr sz="900" b="1">
+                          <a:solidFill>
+                            <a:srgbClr val="0F172A"/>
+                          </a:solidFill>
+                        </a:defRPr>
+                      </a:pPr>
+                      <a:r>
+                        <a:t>DHARA R</a:t>
+                      </a:r>
+                    </a:p>
+                  </a:txBody>
+                  <a:tcPr anchor="ctr">
+                    <a:solidFill>
+                      <a:srgbClr val="F5F8FA"/>
+                    </a:solidFill>
+                  </a:tcPr>
+                </a:tc>
+                <a:tc>
+                  <a:txBody>
+                    <a:bodyPr wrap="square" lIns="73152" rIns="73152" tIns="73152" bIns="73152"/>
+                    <a:lstStyle/>
+                    <a:p>
+                      <a:pPr>
+                        <a:defRPr sz="900">
+                          <a:solidFill>
+                            <a:srgbClr val="0F172A"/>
+                          </a:solidFill>
+                        </a:defRPr>
+                      </a:pPr>
+                      <a:r>
+                        <a:t>B.E</a:t>
+                      </a:r>
+                    </a:p>
+                  </a:txBody>
+                  <a:tcPr anchor="ctr">
+                    <a:solidFill>
+                      <a:srgbClr val="F5F8FA"/>
+                    </a:solidFill>
+                  </a:tcPr>
+                </a:tc>
+                <a:tc>
+                  <a:txBody>
+                    <a:bodyPr wrap="square" lIns="73152" rIns="73152" tIns="73152" bIns="73152"/>
+                    <a:lstStyle/>
+                    <a:p>
+                      <a:pPr>
+                        <a:defRPr sz="900">
+                          <a:solidFill>
+                            <a:srgbClr val="0F172A"/>
+                          </a:solidFill>
+                        </a:defRPr>
+                      </a:pPr>
+                      <a:r>
+                        <a:t>CSE</a:t>
+                      </a:r>
+                    </a:p>
+                  </a:txBody>
+                  <a:tcPr anchor="ctr">
+                    <a:solidFill>
+                      <a:srgbClr val="F5F8FA"/>
+                    </a:solidFill>
+                  </a:tcPr>
+                </a:tc>
+                <a:tc>
+                  <a:txBody>
+                    <a:bodyPr wrap="square" lIns="73152" rIns="73152" tIns="73152" bIns="73152"/>
+                    <a:lstStyle/>
+                    <a:p>
+                      <a:pPr>
+                        <a:defRPr sz="900">
+                          <a:solidFill>
+                            <a:srgbClr val="0F172A"/>
+                          </a:solidFill>
+                        </a:defRPr>
+                      </a:pPr>
+                      <a:r>
+                        <a:t>IV</a:t>
+                      </a:r>
+                    </a:p>
+                  </a:txBody>
+                  <a:tcPr anchor="ctr">
+                    <a:solidFill>
+                      <a:srgbClr val="F5F8FA"/>
+                    </a:solidFill>
+                  </a:tcPr>
+                </a:tc>
+                <a:tc>
+                  <a:txBody>
+                    <a:bodyPr wrap="square" lIns="73152" rIns="73152" tIns="73152" bIns="73152"/>
+                    <a:lstStyle/>
+                    <a:p>
+                      <a:pPr>
+                        <a:defRPr sz="900">
+                          <a:solidFill>
+                            <a:srgbClr val="0F172A"/>
+                          </a:solidFill>
+                        </a:defRPr>
+                      </a:pPr>
+                      <a:r>
+                        <a:t>TEAM_MEMBER (dhararamesh2416@gmail.com | 9043644162)</a:t>
+                      </a:r>
+                    </a:p>
+                  </a:txBody>
+                  <a:tcPr anchor="ctr">
+                    <a:solidFill>
+                      <a:srgbClr val="F5F8FA"/>
+                    </a:solidFill>
+                  </a:tcPr>
+                </a:tc>
+              </a:tr>
+            </a:tbl>
+          </a:graphicData>
+        </a:graphic>
+      </p:graphicFrame>
     </p:spTree>
     <p:extLst>
       <p:ext uri="{BB962C8B-B14F-4D97-AF65-F5344CB8AC3E}">

</xml_diff>